<commit_message>
modified:   chapter01/ASE_1_SoftwareEngineering.pptx 	modified:   chapter01/ASE_1_intro.pptx
</commit_message>
<xml_diff>
--- a/chapter01/ASE_1_SoftwareEngineering.pptx
+++ b/chapter01/ASE_1_SoftwareEngineering.pptx
@@ -2,69 +2,69 @@
 <file path=ppt/presentation.xml><?xml version="1.0" encoding="utf-8"?>
 <p:presentation xmlns:a="http://schemas.openxmlformats.org/drawingml/2006/main" xmlns:r="http://schemas.openxmlformats.org/officeDocument/2006/relationships" xmlns:p="http://schemas.openxmlformats.org/presentationml/2006/main" showSpecialPlsOnTitleSld="0" strictFirstAndLastChars="0">
   <p:sldMasterIdLst>
-    <p:sldMasterId id="2147483648" r:id="rId1"/>
+    <p:sldMasterId id="2147483648" r:id="rId4"/>
   </p:sldMasterIdLst>
   <p:notesMasterIdLst>
-    <p:notesMasterId r:id="rId4"/>
+    <p:notesMasterId r:id="rId62"/>
   </p:notesMasterIdLst>
   <p:sldIdLst>
-    <p:sldId id="256" r:id="rId3"/>
-    <p:sldId id="333" r:id="rId5"/>
-    <p:sldId id="286" r:id="rId6"/>
-    <p:sldId id="284" r:id="rId7"/>
-    <p:sldId id="287" r:id="rId8"/>
-    <p:sldId id="285" r:id="rId9"/>
-    <p:sldId id="300" r:id="rId10"/>
-    <p:sldId id="334" r:id="rId11"/>
-    <p:sldId id="301" r:id="rId12"/>
-    <p:sldId id="335" r:id="rId13"/>
-    <p:sldId id="302" r:id="rId14"/>
-    <p:sldId id="313" r:id="rId15"/>
-    <p:sldId id="336" r:id="rId16"/>
-    <p:sldId id="319" r:id="rId17"/>
-    <p:sldId id="320" r:id="rId18"/>
-    <p:sldId id="321" r:id="rId19"/>
-    <p:sldId id="311" r:id="rId20"/>
-    <p:sldId id="303" r:id="rId21"/>
-    <p:sldId id="295" r:id="rId22"/>
-    <p:sldId id="296" r:id="rId23"/>
-    <p:sldId id="294" r:id="rId24"/>
-    <p:sldId id="315" r:id="rId25"/>
-    <p:sldId id="314" r:id="rId26"/>
-    <p:sldId id="329" r:id="rId27"/>
-    <p:sldId id="346" r:id="rId28"/>
-    <p:sldId id="347" r:id="rId29"/>
-    <p:sldId id="348" r:id="rId30"/>
-    <p:sldId id="375" r:id="rId31"/>
-    <p:sldId id="349" r:id="rId32"/>
-    <p:sldId id="350" r:id="rId33"/>
-    <p:sldId id="351" r:id="rId34"/>
-    <p:sldId id="322" r:id="rId35"/>
-    <p:sldId id="291" r:id="rId36"/>
-    <p:sldId id="345" r:id="rId37"/>
-    <p:sldId id="343" r:id="rId38"/>
-    <p:sldId id="344" r:id="rId39"/>
-    <p:sldId id="305" r:id="rId40"/>
-    <p:sldId id="306" r:id="rId41"/>
-    <p:sldId id="307" r:id="rId42"/>
-    <p:sldId id="323" r:id="rId43"/>
-    <p:sldId id="324" r:id="rId44"/>
-    <p:sldId id="339" r:id="rId45"/>
-    <p:sldId id="340" r:id="rId46"/>
-    <p:sldId id="341" r:id="rId47"/>
-    <p:sldId id="342" r:id="rId48"/>
-    <p:sldId id="352" r:id="rId49"/>
-    <p:sldId id="353" r:id="rId50"/>
-    <p:sldId id="325" r:id="rId51"/>
-    <p:sldId id="354" r:id="rId52"/>
-    <p:sldId id="356" r:id="rId53"/>
-    <p:sldId id="357" r:id="rId54"/>
-    <p:sldId id="355" r:id="rId55"/>
-    <p:sldId id="326" r:id="rId56"/>
-    <p:sldId id="337" r:id="rId57"/>
-    <p:sldId id="304" r:id="rId58"/>
-    <p:sldId id="318" r:id="rId59"/>
-    <p:sldId id="330" r:id="rId60"/>
+    <p:sldId id="256" r:id="rId5"/>
+    <p:sldId id="333" r:id="rId6"/>
+    <p:sldId id="286" r:id="rId7"/>
+    <p:sldId id="284" r:id="rId8"/>
+    <p:sldId id="287" r:id="rId9"/>
+    <p:sldId id="285" r:id="rId10"/>
+    <p:sldId id="300" r:id="rId11"/>
+    <p:sldId id="334" r:id="rId12"/>
+    <p:sldId id="301" r:id="rId13"/>
+    <p:sldId id="335" r:id="rId14"/>
+    <p:sldId id="302" r:id="rId15"/>
+    <p:sldId id="313" r:id="rId16"/>
+    <p:sldId id="336" r:id="rId17"/>
+    <p:sldId id="319" r:id="rId18"/>
+    <p:sldId id="320" r:id="rId19"/>
+    <p:sldId id="321" r:id="rId20"/>
+    <p:sldId id="311" r:id="rId21"/>
+    <p:sldId id="303" r:id="rId22"/>
+    <p:sldId id="295" r:id="rId23"/>
+    <p:sldId id="296" r:id="rId24"/>
+    <p:sldId id="294" r:id="rId25"/>
+    <p:sldId id="315" r:id="rId26"/>
+    <p:sldId id="314" r:id="rId27"/>
+    <p:sldId id="329" r:id="rId28"/>
+    <p:sldId id="346" r:id="rId29"/>
+    <p:sldId id="347" r:id="rId30"/>
+    <p:sldId id="348" r:id="rId31"/>
+    <p:sldId id="375" r:id="rId32"/>
+    <p:sldId id="349" r:id="rId33"/>
+    <p:sldId id="350" r:id="rId34"/>
+    <p:sldId id="351" r:id="rId35"/>
+    <p:sldId id="322" r:id="rId36"/>
+    <p:sldId id="291" r:id="rId37"/>
+    <p:sldId id="345" r:id="rId38"/>
+    <p:sldId id="343" r:id="rId39"/>
+    <p:sldId id="344" r:id="rId40"/>
+    <p:sldId id="305" r:id="rId41"/>
+    <p:sldId id="306" r:id="rId42"/>
+    <p:sldId id="307" r:id="rId43"/>
+    <p:sldId id="323" r:id="rId44"/>
+    <p:sldId id="324" r:id="rId45"/>
+    <p:sldId id="339" r:id="rId46"/>
+    <p:sldId id="340" r:id="rId47"/>
+    <p:sldId id="341" r:id="rId48"/>
+    <p:sldId id="342" r:id="rId49"/>
+    <p:sldId id="352" r:id="rId50"/>
+    <p:sldId id="353" r:id="rId51"/>
+    <p:sldId id="325" r:id="rId52"/>
+    <p:sldId id="354" r:id="rId53"/>
+    <p:sldId id="356" r:id="rId54"/>
+    <p:sldId id="357" r:id="rId55"/>
+    <p:sldId id="355" r:id="rId56"/>
+    <p:sldId id="326" r:id="rId57"/>
+    <p:sldId id="337" r:id="rId58"/>
+    <p:sldId id="304" r:id="rId59"/>
+    <p:sldId id="318" r:id="rId60"/>
+    <p:sldId id="330" r:id="rId61"/>
   </p:sldIdLst>
   <p:sldSz cx="12192000" cy="6858000"/>
   <p:notesSz cx="6858000" cy="9144000"/>
@@ -300,6 +300,7 @@
             </a:pPr>
             <a:fld id="{D9FE4259-CDD9-4688-807A-933F5020E247}" type="datetimeFigureOut">
               <a:rPr lang="en-US"/>
+              <a:t>5/26/2026</a:t>
             </a:fld>
             <a:endParaRPr lang="en-US"/>
           </a:p>
@@ -369,7 +370,6 @@
               <a:rPr lang="en-US" noProof="0"/>
               <a:t>Click to edit Master text styles</a:t>
             </a:r>
-            <a:endParaRPr lang="en-US" noProof="0"/>
           </a:p>
           <a:p>
             <a:pPr lvl="1"/>
@@ -377,7 +377,6 @@
               <a:rPr lang="en-US" noProof="0"/>
               <a:t>Second level</a:t>
             </a:r>
-            <a:endParaRPr lang="en-US" noProof="0"/>
           </a:p>
           <a:p>
             <a:pPr lvl="2"/>
@@ -385,7 +384,6 @@
               <a:rPr lang="en-US" noProof="0"/>
               <a:t>Third level</a:t>
             </a:r>
-            <a:endParaRPr lang="en-US" noProof="0"/>
           </a:p>
           <a:p>
             <a:pPr lvl="3"/>
@@ -393,7 +391,6 @@
               <a:rPr lang="en-US" noProof="0"/>
               <a:t>Fourth level</a:t>
             </a:r>
-            <a:endParaRPr lang="en-US" noProof="0"/>
           </a:p>
           <a:p>
             <a:pPr lvl="4"/>
@@ -401,7 +398,6 @@
               <a:rPr lang="en-US" noProof="0"/>
               <a:t>Fifth level</a:t>
             </a:r>
-            <a:endParaRPr lang="en-US" noProof="0"/>
           </a:p>
         </p:txBody>
       </p:sp>
@@ -471,6 +467,7 @@
             </a:pPr>
             <a:fld id="{C5ADAB1E-5BE0-4555-8709-524C8D586A6B}" type="slidenum">
               <a:rPr lang="en-US"/>
+              <a:t>‹#›</a:t>
             </a:fld>
             <a:endParaRPr lang="en-US"/>
           </a:p>
@@ -677,6 +674,7 @@
             </a:pPr>
             <a:fld id="{C5ADAB1E-5BE0-4555-8709-524C8D586A6B}" type="slidenum">
               <a:rPr lang="en-US" smtClean="0"/>
+              <a:t>1</a:t>
             </a:fld>
             <a:endParaRPr lang="en-US"/>
           </a:p>
@@ -797,7 +795,6 @@
               <a:rPr lang="en-US" altLang="zh-CN" sz="2200" dirty="0"/>
               <a:t>Quiz – housing &amp; 1Billion$</a:t>
             </a:r>
-            <a:endParaRPr lang="en-US" altLang="zh-CN" sz="2200" dirty="0"/>
           </a:p>
           <a:p>
             <a:pPr eaLnBrk="1" hangingPunct="1">
@@ -944,6 +941,7 @@
           <a:p>
             <a:fld id="{9FA30708-CCA8-4933-B01C-46738CEF215D}" type="slidenum">
               <a:rPr lang="en-US" smtClean="0"/>
+              <a:t>33</a:t>
             </a:fld>
             <a:endParaRPr lang="en-US"/>
           </a:p>
@@ -1182,6 +1180,7 @@
           <a:p>
             <a:fld id="{3F4CE25E-E002-44E5-ACD7-66C89E0F12B2}" type="slidenum">
               <a:rPr lang="en-US" smtClean="0"/>
+              <a:t>38</a:t>
             </a:fld>
             <a:endParaRPr lang="en-US"/>
           </a:p>
@@ -1268,6 +1267,7 @@
             </a:pPr>
             <a:fld id="{C5ADAB1E-5BE0-4555-8709-524C8D586A6B}" type="slidenum">
               <a:rPr lang="en-US" smtClean="0"/>
+              <a:t>46</a:t>
             </a:fld>
             <a:endParaRPr lang="en-US"/>
           </a:p>
@@ -1369,7 +1369,6 @@
               <a:rPr lang="en-US" dirty="0"/>
               <a:t>	http://www.wuji8.com/meta/565085646.html</a:t>
             </a:r>
-            <a:endParaRPr lang="en-US" dirty="0"/>
           </a:p>
           <a:p>
             <a:endParaRPr lang="en-US" dirty="0"/>
@@ -1396,6 +1395,7 @@
             </a:pPr>
             <a:fld id="{C5ADAB1E-5BE0-4555-8709-524C8D586A6B}" type="slidenum">
               <a:rPr lang="en-US" smtClean="0"/>
+              <a:t>54</a:t>
             </a:fld>
             <a:endParaRPr lang="en-US"/>
           </a:p>
@@ -1871,6 +1871,7 @@
           <a:p>
             <a:fld id="{2551ACDB-B434-4061-BA28-70898E2A9AA7}" type="slidenum">
               <a:rPr lang="en-US" smtClean="0"/>
+              <a:t>4</a:t>
             </a:fld>
             <a:endParaRPr lang="en-US"/>
           </a:p>
@@ -1984,7 +1985,7 @@
             </a:r>
             <a:r>
               <a:rPr lang="en-US">
-                <a:hlinkClick r:id="rId3" tooltip="Brian Randell" action="ppaction://hlinkfile"/>
+                <a:hlinkClick r:id="rId3" action="ppaction://hlinkfile" tooltip="Brian Randell"/>
               </a:rPr>
               <a:t>Brian Randell</a:t>
             </a:r>
@@ -1994,7 +1995,7 @@
             </a:r>
             <a:r>
               <a:rPr lang="en-US">
-                <a:hlinkClick r:id="rId4" tooltip="F.L. Bauer" action="ppaction://hlinkfile"/>
+                <a:hlinkClick r:id="rId4" action="ppaction://hlinkfile" tooltip="F.L. Bauer"/>
               </a:rPr>
               <a:t>F.L. Bauer</a:t>
             </a:r>
@@ -2014,7 +2015,7 @@
             </a:r>
             <a:r>
               <a:rPr lang="en-US">
-                <a:hlinkClick r:id="rId6" tooltip="Requirements analysis" action="ppaction://hlinkfile"/>
+                <a:hlinkClick r:id="rId6" action="ppaction://hlinkfile" tooltip="Requirements analysis"/>
               </a:rPr>
               <a:t>software requirements</a:t>
             </a:r>
@@ -2024,7 +2025,7 @@
             </a:r>
             <a:r>
               <a:rPr lang="en-US">
-                <a:hlinkClick r:id="rId7" tooltip="Software design" action="ppaction://hlinkfile"/>
+                <a:hlinkClick r:id="rId7" action="ppaction://hlinkfile" tooltip="Software design"/>
               </a:rPr>
               <a:t>software design</a:t>
             </a:r>
@@ -2034,7 +2035,7 @@
             </a:r>
             <a:r>
               <a:rPr lang="en-US">
-                <a:hlinkClick r:id="rId8" tooltip="Computer programming" action="ppaction://hlinkfile"/>
+                <a:hlinkClick r:id="rId8" action="ppaction://hlinkfile" tooltip="Computer programming"/>
               </a:rPr>
               <a:t>software construction</a:t>
             </a:r>
@@ -2044,7 +2045,7 @@
             </a:r>
             <a:r>
               <a:rPr lang="en-US">
-                <a:hlinkClick r:id="rId9" tooltip="Software testing" action="ppaction://hlinkfile"/>
+                <a:hlinkClick r:id="rId9" action="ppaction://hlinkfile" tooltip="Software testing"/>
               </a:rPr>
               <a:t>software testing</a:t>
             </a:r>
@@ -2054,7 +2055,7 @@
             </a:r>
             <a:r>
               <a:rPr lang="en-US">
-                <a:hlinkClick r:id="rId10" tooltip="Software maintenance" action="ppaction://hlinkfile"/>
+                <a:hlinkClick r:id="rId10" action="ppaction://hlinkfile" tooltip="Software maintenance"/>
               </a:rPr>
               <a:t>software maintenance</a:t>
             </a:r>
@@ -2074,7 +2075,7 @@
             </a:r>
             <a:r>
               <a:rPr lang="en-US">
-                <a:hlinkClick r:id="rId12" tooltip="Computer science" action="ppaction://hlinkfile"/>
+                <a:hlinkClick r:id="rId12" action="ppaction://hlinkfile" tooltip="Computer science"/>
               </a:rPr>
               <a:t>computer science</a:t>
             </a:r>
@@ -2084,7 +2085,7 @@
             </a:r>
             <a:r>
               <a:rPr lang="en-US">
-                <a:hlinkClick r:id="rId13" tooltip="Computer engineering" action="ppaction://hlinkfile"/>
+                <a:hlinkClick r:id="rId13" action="ppaction://hlinkfile" tooltip="Computer engineering"/>
               </a:rPr>
               <a:t>computer engineering</a:t>
             </a:r>
@@ -2094,7 +2095,7 @@
             </a:r>
             <a:r>
               <a:rPr lang="en-US">
-                <a:hlinkClick r:id="rId14" tooltip="Management" action="ppaction://hlinkfile"/>
+                <a:hlinkClick r:id="rId14" action="ppaction://hlinkfile" tooltip="Management"/>
               </a:rPr>
               <a:t>management</a:t>
             </a:r>
@@ -2104,7 +2105,7 @@
             </a:r>
             <a:r>
               <a:rPr lang="en-US">
-                <a:hlinkClick r:id="rId15" tooltip="Mathematics" action="ppaction://hlinkfile"/>
+                <a:hlinkClick r:id="rId15" action="ppaction://hlinkfile" tooltip="Mathematics"/>
               </a:rPr>
               <a:t>mathematics</a:t>
             </a:r>
@@ -2114,7 +2115,7 @@
             </a:r>
             <a:r>
               <a:rPr lang="en-US">
-                <a:hlinkClick r:id="rId16" tooltip="Project management" action="ppaction://hlinkfile"/>
+                <a:hlinkClick r:id="rId16" action="ppaction://hlinkfile" tooltip="Project management"/>
               </a:rPr>
               <a:t>project management</a:t>
             </a:r>
@@ -2124,7 +2125,7 @@
             </a:r>
             <a:r>
               <a:rPr lang="en-US">
-                <a:hlinkClick r:id="rId17" tooltip="Quality management" action="ppaction://hlinkfile"/>
+                <a:hlinkClick r:id="rId17" action="ppaction://hlinkfile" tooltip="Quality management"/>
               </a:rPr>
               <a:t>quality management</a:t>
             </a:r>
@@ -2134,7 +2135,7 @@
             </a:r>
             <a:r>
               <a:rPr lang="en-US">
-                <a:hlinkClick r:id="rId18" tooltip="Ergonomics" action="ppaction://hlinkfile"/>
+                <a:hlinkClick r:id="rId18" action="ppaction://hlinkfile" tooltip="Ergonomics"/>
               </a:rPr>
               <a:t>ergonomics</a:t>
             </a:r>
@@ -2144,7 +2145,7 @@
             </a:r>
             <a:r>
               <a:rPr lang="en-US">
-                <a:hlinkClick r:id="rId19" tooltip="Systems engineering" action="ppaction://hlinkfile"/>
+                <a:hlinkClick r:id="rId19" action="ppaction://hlinkfile" tooltip="Systems engineering"/>
               </a:rPr>
               <a:t>systems engineering</a:t>
             </a:r>
@@ -2300,6 +2301,7 @@
           <a:p>
             <a:fld id="{97989AEB-0172-4163-907A-0644FD1BC23F}" type="slidenum">
               <a:rPr lang="en-US" smtClean="0"/>
+              <a:t>7</a:t>
             </a:fld>
             <a:endParaRPr lang="en-US"/>
           </a:p>
@@ -2539,6 +2541,7 @@
           <a:p>
             <a:fld id="{C95BD9B2-E9EE-4A05-9F7C-A035C87EA3D1}" type="slidenum">
               <a:rPr lang="en-US" smtClean="0"/>
+              <a:t>19</a:t>
             </a:fld>
             <a:endParaRPr lang="en-US"/>
           </a:p>
@@ -2643,7 +2646,6 @@
               <a:rPr lang="en-US" dirty="0"/>
               <a:t>Each month, there are about 1-2 flight accidents involving use of flight safety equipment. </a:t>
             </a:r>
-            <a:endParaRPr lang="en-US" dirty="0"/>
           </a:p>
           <a:p>
             <a:pPr eaLnBrk="1" hangingPunct="1"/>
@@ -2655,7 +2657,6 @@
               <a:rPr lang="en-US" dirty="0"/>
               <a:t>The total number of flights scheduled to operate worldwide this month is 2.55 million, offering 306.9 million seats to travelers around the globe. </a:t>
             </a:r>
-            <a:endParaRPr lang="en-US" dirty="0"/>
           </a:p>
           <a:p>
             <a:pPr eaLnBrk="1" hangingPunct="1"/>
@@ -2667,7 +2668,6 @@
               <a:rPr lang="en-US" dirty="0"/>
               <a:t>http://portal.antara.co.id/en/arc/2008/5/16/slowdown-in-growth-rate-of-flights-worldwide/</a:t>
             </a:r>
-            <a:endParaRPr lang="en-US" dirty="0"/>
           </a:p>
           <a:p>
             <a:pPr eaLnBrk="1" hangingPunct="1"/>
@@ -2810,6 +2810,7 @@
           <a:p>
             <a:fld id="{3A2928E0-FC3A-4241-9402-C30252AEB309}" type="slidenum">
               <a:rPr lang="en-US" smtClean="0"/>
+              <a:t>21</a:t>
             </a:fld>
             <a:endParaRPr lang="en-US"/>
           </a:p>
@@ -2876,7 +2877,6 @@
               <a:rPr lang="en-US" dirty="0"/>
               <a:t>https://en.wikipedia.org/wiki/US_Airways_Flight_1549</a:t>
             </a:r>
-            <a:endParaRPr lang="en-US" dirty="0"/>
           </a:p>
           <a:p>
             <a:endParaRPr lang="en-US" dirty="0"/>
@@ -2889,7 +2889,6 @@
               <a:rPr lang="en-US" dirty="0"/>
               <a:t>https://www.youtube.com/watch?v=imDFSnklB0k</a:t>
             </a:r>
-            <a:endParaRPr lang="en-US" dirty="0"/>
           </a:p>
           <a:p>
             <a:endParaRPr lang="en-US" dirty="0"/>
@@ -2916,6 +2915,7 @@
             </a:pPr>
             <a:fld id="{C5ADAB1E-5BE0-4555-8709-524C8D586A6B}" type="slidenum">
               <a:rPr lang="en-US" smtClean="0"/>
+              <a:t>23</a:t>
             </a:fld>
             <a:endParaRPr lang="en-US"/>
           </a:p>
@@ -3006,6 +3006,7 @@
             </a:pPr>
             <a:fld id="{C5ADAB1E-5BE0-4555-8709-524C8D586A6B}" type="slidenum">
               <a:rPr lang="en-US" smtClean="0"/>
+              <a:t>25</a:t>
             </a:fld>
             <a:endParaRPr lang="en-US"/>
           </a:p>
@@ -3127,7 +3128,6 @@
               <a:rPr lang="zh-CN" altLang="en-US" dirty="0"/>
               <a:t>）其他方面的知识</a:t>
             </a:r>
-            <a:endParaRPr lang="zh-CN" altLang="en-US" dirty="0"/>
           </a:p>
         </p:txBody>
       </p:sp>
@@ -3151,6 +3151,7 @@
             </a:pPr>
             <a:fld id="{C5ADAB1E-5BE0-4555-8709-524C8D586A6B}" type="slidenum">
               <a:rPr lang="en-US" smtClean="0"/>
+              <a:t>28</a:t>
             </a:fld>
             <a:endParaRPr lang="en-US"/>
           </a:p>
@@ -3233,7 +3234,6 @@
               <a:rPr lang="zh-CN" altLang="en-US" dirty="0"/>
               <a:t>软件的这些本质特性让 “做一个好软件”变得很难，同时也让软件工程有它独特的挑战和魅力。</a:t>
             </a:r>
-            <a:endParaRPr lang="zh-CN" altLang="en-US" dirty="0"/>
           </a:p>
           <a:p>
             <a:endParaRPr lang="en-US" dirty="0"/>
@@ -3260,6 +3260,7 @@
             </a:pPr>
             <a:fld id="{C5ADAB1E-5BE0-4555-8709-524C8D586A6B}" type="slidenum">
               <a:rPr lang="en-US" smtClean="0"/>
+              <a:t>31</a:t>
             </a:fld>
             <a:endParaRPr lang="en-US"/>
           </a:p>
@@ -3469,6 +3470,7 @@
           <a:p>
             <a:fld id="{48A87A34-81AB-432B-8DAE-1953F412C126}" type="datetimeFigureOut">
               <a:rPr lang="en-US" smtClean="0"/>
+              <a:t>5/26/2026</a:t>
             </a:fld>
             <a:endParaRPr lang="en-US" dirty="0"/>
           </a:p>
@@ -3510,6 +3512,7 @@
           <a:p>
             <a:fld id="{6D22F896-40B5-4ADD-8801-0D06FADFA095}" type="slidenum">
               <a:rPr lang="en-US" smtClean="0"/>
+              <a:t>‹#›</a:t>
             </a:fld>
             <a:endParaRPr lang="en-US" dirty="0"/>
           </a:p>
@@ -3723,7 +3726,6 @@
               <a:rPr lang="en-US"/>
               <a:t>Edit Master text styles</a:t>
             </a:r>
-            <a:endParaRPr lang="en-US"/>
           </a:p>
         </p:txBody>
       </p:sp>
@@ -3744,6 +3746,7 @@
           <a:p>
             <a:fld id="{48A87A34-81AB-432B-8DAE-1953F412C126}" type="datetimeFigureOut">
               <a:rPr lang="en-US" smtClean="0"/>
+              <a:t>5/26/2026</a:t>
             </a:fld>
             <a:endParaRPr lang="en-US" dirty="0"/>
           </a:p>
@@ -3785,6 +3788,7 @@
           <a:p>
             <a:fld id="{6D22F896-40B5-4ADD-8801-0D06FADFA095}" type="slidenum">
               <a:rPr lang="en-US" smtClean="0"/>
+              <a:t>‹#›</a:t>
             </a:fld>
             <a:endParaRPr lang="en-US" dirty="0"/>
           </a:p>
@@ -3909,7 +3913,6 @@
               <a:rPr lang="en-US"/>
               <a:t>Edit Master text styles</a:t>
             </a:r>
-            <a:endParaRPr lang="en-US"/>
           </a:p>
         </p:txBody>
       </p:sp>
@@ -3930,6 +3933,7 @@
           <a:p>
             <a:fld id="{48A87A34-81AB-432B-8DAE-1953F412C126}" type="datetimeFigureOut">
               <a:rPr lang="en-US" smtClean="0"/>
+              <a:t>5/26/2026</a:t>
             </a:fld>
             <a:endParaRPr lang="en-US" dirty="0"/>
           </a:p>
@@ -3971,6 +3975,7 @@
           <a:p>
             <a:fld id="{6D22F896-40B5-4ADD-8801-0D06FADFA095}" type="slidenum">
               <a:rPr lang="en-US" smtClean="0"/>
+              <a:t>‹#›</a:t>
             </a:fld>
             <a:endParaRPr lang="en-US" dirty="0"/>
           </a:p>
@@ -4097,7 +4102,6 @@
               <a:rPr lang="en-US"/>
               <a:t>Edit Master text styles</a:t>
             </a:r>
-            <a:endParaRPr lang="en-US"/>
           </a:p>
         </p:txBody>
       </p:sp>
@@ -4165,7 +4169,6 @@
               <a:rPr lang="en-US"/>
               <a:t>Edit Master text styles</a:t>
             </a:r>
-            <a:endParaRPr lang="en-US"/>
           </a:p>
         </p:txBody>
       </p:sp>
@@ -4186,6 +4189,7 @@
           <a:p>
             <a:fld id="{48A87A34-81AB-432B-8DAE-1953F412C126}" type="datetimeFigureOut">
               <a:rPr lang="en-US" smtClean="0"/>
+              <a:t>5/26/2026</a:t>
             </a:fld>
             <a:endParaRPr lang="en-US" dirty="0"/>
           </a:p>
@@ -4227,6 +4231,7 @@
           <a:p>
             <a:fld id="{6D22F896-40B5-4ADD-8801-0D06FADFA095}" type="slidenum">
               <a:rPr lang="en-US" smtClean="0"/>
+              <a:t>‹#›</a:t>
             </a:fld>
             <a:endParaRPr lang="en-US" dirty="0"/>
           </a:p>
@@ -4345,12 +4350,6 @@
               </a:rPr>
               <a:t>“</a:t>
             </a:r>
-            <a:endParaRPr lang="en-US" sz="8000" dirty="0">
-              <a:solidFill>
-                <a:schemeClr val="tx1"/>
-              </a:solidFill>
-              <a:effectLst/>
-            </a:endParaRPr>
           </a:p>
         </p:txBody>
       </p:sp>
@@ -4467,12 +4466,6 @@
               </a:rPr>
               <a:t>”</a:t>
             </a:r>
-            <a:endParaRPr lang="en-US" sz="8000" dirty="0">
-              <a:solidFill>
-                <a:schemeClr val="tx1"/>
-              </a:solidFill>
-              <a:effectLst/>
-            </a:endParaRPr>
           </a:p>
         </p:txBody>
       </p:sp>
@@ -4597,7 +4590,6 @@
               <a:rPr lang="en-US"/>
               <a:t>Edit Master text styles</a:t>
             </a:r>
-            <a:endParaRPr lang="en-US"/>
           </a:p>
         </p:txBody>
       </p:sp>
@@ -4618,6 +4610,7 @@
           <a:p>
             <a:fld id="{48A87A34-81AB-432B-8DAE-1953F412C126}" type="datetimeFigureOut">
               <a:rPr lang="en-US" smtClean="0"/>
+              <a:t>5/26/2026</a:t>
             </a:fld>
             <a:endParaRPr lang="en-US" dirty="0"/>
           </a:p>
@@ -4659,6 +4652,7 @@
           <a:p>
             <a:fld id="{6D22F896-40B5-4ADD-8801-0D06FADFA095}" type="slidenum">
               <a:rPr lang="en-US" smtClean="0"/>
+              <a:t>‹#›</a:t>
             </a:fld>
             <a:endParaRPr lang="en-US" dirty="0"/>
           </a:p>
@@ -4808,7 +4802,6 @@
               <a:rPr lang="en-US"/>
               <a:t>Edit Master text styles</a:t>
             </a:r>
-            <a:endParaRPr lang="en-US"/>
           </a:p>
         </p:txBody>
       </p:sp>
@@ -4876,7 +4869,6 @@
               <a:rPr lang="en-US"/>
               <a:t>Edit Master text styles</a:t>
             </a:r>
-            <a:endParaRPr lang="en-US"/>
           </a:p>
         </p:txBody>
       </p:sp>
@@ -4941,7 +4933,6 @@
               <a:rPr lang="en-US"/>
               <a:t>Edit Master text styles</a:t>
             </a:r>
-            <a:endParaRPr lang="en-US"/>
           </a:p>
         </p:txBody>
       </p:sp>
@@ -5009,7 +5000,6 @@
               <a:rPr lang="en-US"/>
               <a:t>Edit Master text styles</a:t>
             </a:r>
-            <a:endParaRPr lang="en-US"/>
           </a:p>
         </p:txBody>
       </p:sp>
@@ -5074,7 +5064,6 @@
               <a:rPr lang="en-US"/>
               <a:t>Edit Master text styles</a:t>
             </a:r>
-            <a:endParaRPr lang="en-US"/>
           </a:p>
         </p:txBody>
       </p:sp>
@@ -5142,7 +5131,6 @@
               <a:rPr lang="en-US"/>
               <a:t>Edit Master text styles</a:t>
             </a:r>
-            <a:endParaRPr lang="en-US"/>
           </a:p>
         </p:txBody>
       </p:sp>
@@ -5163,6 +5151,7 @@
           <a:p>
             <a:fld id="{48A87A34-81AB-432B-8DAE-1953F412C126}" type="datetimeFigureOut">
               <a:rPr lang="en-US" smtClean="0"/>
+              <a:t>5/26/2026</a:t>
             </a:fld>
             <a:endParaRPr lang="en-US" dirty="0"/>
           </a:p>
@@ -5204,6 +5193,7 @@
           <a:p>
             <a:fld id="{6D22F896-40B5-4ADD-8801-0D06FADFA095}" type="slidenum">
               <a:rPr lang="en-US" smtClean="0"/>
+              <a:t>‹#›</a:t>
             </a:fld>
             <a:endParaRPr lang="en-US" dirty="0"/>
           </a:p>
@@ -5349,7 +5339,6 @@
               <a:rPr lang="en-US"/>
               <a:t>Edit Master text styles</a:t>
             </a:r>
-            <a:endParaRPr lang="en-US"/>
           </a:p>
         </p:txBody>
       </p:sp>
@@ -5496,7 +5485,6 @@
               <a:rPr lang="en-US"/>
               <a:t>Edit Master text styles</a:t>
             </a:r>
-            <a:endParaRPr lang="en-US"/>
           </a:p>
         </p:txBody>
       </p:sp>
@@ -5587,7 +5575,6 @@
               <a:rPr lang="en-US"/>
               <a:t>Edit Master text styles</a:t>
             </a:r>
-            <a:endParaRPr lang="en-US"/>
           </a:p>
         </p:txBody>
       </p:sp>
@@ -5734,7 +5721,6 @@
               <a:rPr lang="en-US"/>
               <a:t>Edit Master text styles</a:t>
             </a:r>
-            <a:endParaRPr lang="en-US"/>
           </a:p>
         </p:txBody>
       </p:sp>
@@ -5825,7 +5811,6 @@
               <a:rPr lang="en-US"/>
               <a:t>Edit Master text styles</a:t>
             </a:r>
-            <a:endParaRPr lang="en-US"/>
           </a:p>
         </p:txBody>
       </p:sp>
@@ -5972,7 +5957,6 @@
               <a:rPr lang="en-US"/>
               <a:t>Edit Master text styles</a:t>
             </a:r>
-            <a:endParaRPr lang="en-US"/>
           </a:p>
         </p:txBody>
       </p:sp>
@@ -5993,6 +5977,7 @@
           <a:p>
             <a:fld id="{48A87A34-81AB-432B-8DAE-1953F412C126}" type="datetimeFigureOut">
               <a:rPr lang="en-US" smtClean="0"/>
+              <a:t>5/26/2026</a:t>
             </a:fld>
             <a:endParaRPr lang="en-US" dirty="0"/>
           </a:p>
@@ -6034,6 +6019,7 @@
           <a:p>
             <a:fld id="{6D22F896-40B5-4ADD-8801-0D06FADFA095}" type="slidenum">
               <a:rPr lang="en-US" smtClean="0"/>
+              <a:t>‹#›</a:t>
             </a:fld>
             <a:endParaRPr lang="en-US" dirty="0"/>
           </a:p>
@@ -6107,7 +6093,6 @@
               <a:rPr lang="en-US"/>
               <a:t>Edit Master text styles</a:t>
             </a:r>
-            <a:endParaRPr lang="en-US"/>
           </a:p>
           <a:p>
             <a:pPr lvl="1"/>
@@ -6115,7 +6100,6 @@
               <a:rPr lang="en-US"/>
               <a:t>Second level</a:t>
             </a:r>
-            <a:endParaRPr lang="en-US"/>
           </a:p>
           <a:p>
             <a:pPr lvl="2"/>
@@ -6123,7 +6107,6 @@
               <a:rPr lang="en-US"/>
               <a:t>Third level</a:t>
             </a:r>
-            <a:endParaRPr lang="en-US"/>
           </a:p>
           <a:p>
             <a:pPr lvl="3"/>
@@ -6131,7 +6114,6 @@
               <a:rPr lang="en-US"/>
               <a:t>Fourth level</a:t>
             </a:r>
-            <a:endParaRPr lang="en-US"/>
           </a:p>
           <a:p>
             <a:pPr lvl="4"/>
@@ -6160,6 +6142,7 @@
           <a:p>
             <a:fld id="{48A87A34-81AB-432B-8DAE-1953F412C126}" type="datetimeFigureOut">
               <a:rPr lang="en-US" smtClean="0"/>
+              <a:t>5/26/2026</a:t>
             </a:fld>
             <a:endParaRPr lang="en-US" dirty="0"/>
           </a:p>
@@ -6201,6 +6184,7 @@
           <a:p>
             <a:fld id="{6D22F896-40B5-4ADD-8801-0D06FADFA095}" type="slidenum">
               <a:rPr lang="en-US" smtClean="0"/>
+              <a:t>‹#›</a:t>
             </a:fld>
             <a:endParaRPr lang="en-US" dirty="0"/>
           </a:p>
@@ -6284,7 +6268,6 @@
               <a:rPr lang="en-US"/>
               <a:t>Edit Master text styles</a:t>
             </a:r>
-            <a:endParaRPr lang="en-US"/>
           </a:p>
           <a:p>
             <a:pPr lvl="1"/>
@@ -6292,7 +6275,6 @@
               <a:rPr lang="en-US"/>
               <a:t>Second level</a:t>
             </a:r>
-            <a:endParaRPr lang="en-US"/>
           </a:p>
           <a:p>
             <a:pPr lvl="2"/>
@@ -6300,7 +6282,6 @@
               <a:rPr lang="en-US"/>
               <a:t>Third level</a:t>
             </a:r>
-            <a:endParaRPr lang="en-US"/>
           </a:p>
           <a:p>
             <a:pPr lvl="3"/>
@@ -6308,7 +6289,6 @@
               <a:rPr lang="en-US"/>
               <a:t>Fourth level</a:t>
             </a:r>
-            <a:endParaRPr lang="en-US"/>
           </a:p>
           <a:p>
             <a:pPr lvl="4"/>
@@ -6337,6 +6317,7 @@
           <a:p>
             <a:fld id="{48A87A34-81AB-432B-8DAE-1953F412C126}" type="datetimeFigureOut">
               <a:rPr lang="en-US" smtClean="0"/>
+              <a:t>5/26/2026</a:t>
             </a:fld>
             <a:endParaRPr lang="en-US" dirty="0"/>
           </a:p>
@@ -6378,6 +6359,7 @@
           <a:p>
             <a:fld id="{6D22F896-40B5-4ADD-8801-0D06FADFA095}" type="slidenum">
               <a:rPr lang="en-US" smtClean="0"/>
+              <a:t>‹#›</a:t>
             </a:fld>
             <a:endParaRPr lang="en-US" dirty="0"/>
           </a:p>
@@ -6451,7 +6433,6 @@
               <a:rPr lang="en-US"/>
               <a:t>Edit Master text styles</a:t>
             </a:r>
-            <a:endParaRPr lang="en-US"/>
           </a:p>
           <a:p>
             <a:pPr lvl="1"/>
@@ -6459,7 +6440,6 @@
               <a:rPr lang="en-US"/>
               <a:t>Second level</a:t>
             </a:r>
-            <a:endParaRPr lang="en-US"/>
           </a:p>
           <a:p>
             <a:pPr lvl="2"/>
@@ -6467,7 +6447,6 @@
               <a:rPr lang="en-US"/>
               <a:t>Third level</a:t>
             </a:r>
-            <a:endParaRPr lang="en-US"/>
           </a:p>
           <a:p>
             <a:pPr lvl="3"/>
@@ -6475,7 +6454,6 @@
               <a:rPr lang="en-US"/>
               <a:t>Fourth level</a:t>
             </a:r>
-            <a:endParaRPr lang="en-US"/>
           </a:p>
           <a:p>
             <a:pPr lvl="4"/>
@@ -6504,6 +6482,7 @@
           <a:p>
             <a:fld id="{48A87A34-81AB-432B-8DAE-1953F412C126}" type="datetimeFigureOut">
               <a:rPr lang="en-US" smtClean="0"/>
+              <a:t>5/26/2026</a:t>
             </a:fld>
             <a:endParaRPr lang="en-US" dirty="0"/>
           </a:p>
@@ -6545,6 +6524,7 @@
           <a:p>
             <a:fld id="{6D22F896-40B5-4ADD-8801-0D06FADFA095}" type="slidenum">
               <a:rPr lang="en-US" smtClean="0"/>
+              <a:t>‹#›</a:t>
             </a:fld>
             <a:endParaRPr lang="en-US" dirty="0"/>
           </a:p>
@@ -6754,6 +6734,7 @@
           <a:p>
             <a:fld id="{48A87A34-81AB-432B-8DAE-1953F412C126}" type="datetimeFigureOut">
               <a:rPr lang="en-US" smtClean="0"/>
+              <a:t>5/26/2026</a:t>
             </a:fld>
             <a:endParaRPr lang="en-US" dirty="0"/>
           </a:p>
@@ -6795,6 +6776,7 @@
           <a:p>
             <a:fld id="{6D22F896-40B5-4ADD-8801-0D06FADFA095}" type="slidenum">
               <a:rPr lang="en-US" smtClean="0"/>
+              <a:t>‹#›</a:t>
             </a:fld>
             <a:endParaRPr lang="en-US" dirty="0"/>
           </a:p>
@@ -6873,7 +6855,6 @@
               <a:rPr lang="en-US"/>
               <a:t>Edit Master text styles</a:t>
             </a:r>
-            <a:endParaRPr lang="en-US"/>
           </a:p>
           <a:p>
             <a:pPr lvl="1"/>
@@ -6881,7 +6862,6 @@
               <a:rPr lang="en-US"/>
               <a:t>Second level</a:t>
             </a:r>
-            <a:endParaRPr lang="en-US"/>
           </a:p>
           <a:p>
             <a:pPr lvl="2"/>
@@ -6889,7 +6869,6 @@
               <a:rPr lang="en-US"/>
               <a:t>Third level</a:t>
             </a:r>
-            <a:endParaRPr lang="en-US"/>
           </a:p>
           <a:p>
             <a:pPr lvl="3"/>
@@ -6897,7 +6876,6 @@
               <a:rPr lang="en-US"/>
               <a:t>Fourth level</a:t>
             </a:r>
-            <a:endParaRPr lang="en-US"/>
           </a:p>
           <a:p>
             <a:pPr lvl="4"/>
@@ -6934,7 +6912,6 @@
               <a:rPr lang="en-US"/>
               <a:t>Edit Master text styles</a:t>
             </a:r>
-            <a:endParaRPr lang="en-US"/>
           </a:p>
           <a:p>
             <a:pPr lvl="1"/>
@@ -6942,7 +6919,6 @@
               <a:rPr lang="en-US"/>
               <a:t>Second level</a:t>
             </a:r>
-            <a:endParaRPr lang="en-US"/>
           </a:p>
           <a:p>
             <a:pPr lvl="2"/>
@@ -6950,7 +6926,6 @@
               <a:rPr lang="en-US"/>
               <a:t>Third level</a:t>
             </a:r>
-            <a:endParaRPr lang="en-US"/>
           </a:p>
           <a:p>
             <a:pPr lvl="3"/>
@@ -6958,7 +6933,6 @@
               <a:rPr lang="en-US"/>
               <a:t>Fourth level</a:t>
             </a:r>
-            <a:endParaRPr lang="en-US"/>
           </a:p>
           <a:p>
             <a:pPr lvl="4"/>
@@ -6987,6 +6961,7 @@
           <a:p>
             <a:fld id="{48A87A34-81AB-432B-8DAE-1953F412C126}" type="datetimeFigureOut">
               <a:rPr lang="en-US" smtClean="0"/>
+              <a:t>5/26/2026</a:t>
             </a:fld>
             <a:endParaRPr lang="en-US" dirty="0"/>
           </a:p>
@@ -7028,6 +7003,7 @@
           <a:p>
             <a:fld id="{6D22F896-40B5-4ADD-8801-0D06FADFA095}" type="slidenum">
               <a:rPr lang="en-US" smtClean="0"/>
+              <a:t>‹#›</a:t>
             </a:fld>
             <a:endParaRPr lang="en-US" dirty="0"/>
           </a:p>
@@ -7175,7 +7151,6 @@
               <a:rPr lang="en-US"/>
               <a:t>Edit Master text styles</a:t>
             </a:r>
-            <a:endParaRPr lang="en-US"/>
           </a:p>
         </p:txBody>
       </p:sp>
@@ -7204,7 +7179,6 @@
               <a:rPr lang="en-US"/>
               <a:t>Edit Master text styles</a:t>
             </a:r>
-            <a:endParaRPr lang="en-US"/>
           </a:p>
           <a:p>
             <a:pPr lvl="1"/>
@@ -7212,7 +7186,6 @@
               <a:rPr lang="en-US"/>
               <a:t>Second level</a:t>
             </a:r>
-            <a:endParaRPr lang="en-US"/>
           </a:p>
           <a:p>
             <a:pPr lvl="2"/>
@@ -7220,7 +7193,6 @@
               <a:rPr lang="en-US"/>
               <a:t>Third level</a:t>
             </a:r>
-            <a:endParaRPr lang="en-US"/>
           </a:p>
           <a:p>
             <a:pPr lvl="3"/>
@@ -7228,7 +7200,6 @@
               <a:rPr lang="en-US"/>
               <a:t>Fourth level</a:t>
             </a:r>
-            <a:endParaRPr lang="en-US"/>
           </a:p>
           <a:p>
             <a:pPr lvl="4"/>
@@ -7301,7 +7272,6 @@
               <a:rPr lang="en-US"/>
               <a:t>Edit Master text styles</a:t>
             </a:r>
-            <a:endParaRPr lang="en-US"/>
           </a:p>
         </p:txBody>
       </p:sp>
@@ -7330,7 +7300,6 @@
               <a:rPr lang="en-US"/>
               <a:t>Edit Master text styles</a:t>
             </a:r>
-            <a:endParaRPr lang="en-US"/>
           </a:p>
           <a:p>
             <a:pPr lvl="1"/>
@@ -7338,7 +7307,6 @@
               <a:rPr lang="en-US"/>
               <a:t>Second level</a:t>
             </a:r>
-            <a:endParaRPr lang="en-US"/>
           </a:p>
           <a:p>
             <a:pPr lvl="2"/>
@@ -7346,7 +7314,6 @@
               <a:rPr lang="en-US"/>
               <a:t>Third level</a:t>
             </a:r>
-            <a:endParaRPr lang="en-US"/>
           </a:p>
           <a:p>
             <a:pPr lvl="3"/>
@@ -7354,7 +7321,6 @@
               <a:rPr lang="en-US"/>
               <a:t>Fourth level</a:t>
             </a:r>
-            <a:endParaRPr lang="en-US"/>
           </a:p>
           <a:p>
             <a:pPr lvl="4"/>
@@ -7383,6 +7349,7 @@
           <a:p>
             <a:fld id="{48A87A34-81AB-432B-8DAE-1953F412C126}" type="datetimeFigureOut">
               <a:rPr lang="en-US" smtClean="0"/>
+              <a:t>5/26/2026</a:t>
             </a:fld>
             <a:endParaRPr lang="en-US" dirty="0"/>
           </a:p>
@@ -7424,6 +7391,7 @@
           <a:p>
             <a:fld id="{6D22F896-40B5-4ADD-8801-0D06FADFA095}" type="slidenum">
               <a:rPr lang="en-US" smtClean="0"/>
+              <a:t>‹#›</a:t>
             </a:fld>
             <a:endParaRPr lang="en-US" dirty="0"/>
           </a:p>
@@ -7494,6 +7462,7 @@
           <a:p>
             <a:fld id="{48A87A34-81AB-432B-8DAE-1953F412C126}" type="datetimeFigureOut">
               <a:rPr lang="en-US" smtClean="0"/>
+              <a:t>5/26/2026</a:t>
             </a:fld>
             <a:endParaRPr lang="en-US" dirty="0"/>
           </a:p>
@@ -7535,6 +7504,7 @@
           <a:p>
             <a:fld id="{6D22F896-40B5-4ADD-8801-0D06FADFA095}" type="slidenum">
               <a:rPr lang="en-US" smtClean="0"/>
+              <a:t>‹#›</a:t>
             </a:fld>
             <a:endParaRPr lang="en-US" dirty="0"/>
           </a:p>
@@ -7582,6 +7552,7 @@
           <a:p>
             <a:fld id="{48A87A34-81AB-432B-8DAE-1953F412C126}" type="datetimeFigureOut">
               <a:rPr lang="en-US" smtClean="0"/>
+              <a:t>5/26/2026</a:t>
             </a:fld>
             <a:endParaRPr lang="en-US" dirty="0"/>
           </a:p>
@@ -7623,6 +7594,7 @@
           <a:p>
             <a:fld id="{6D22F896-40B5-4ADD-8801-0D06FADFA095}" type="slidenum">
               <a:rPr lang="en-US" smtClean="0"/>
+              <a:t>‹#›</a:t>
             </a:fld>
             <a:endParaRPr lang="en-US" dirty="0"/>
           </a:p>
@@ -7710,7 +7682,6 @@
               <a:rPr lang="en-US"/>
               <a:t>Edit Master text styles</a:t>
             </a:r>
-            <a:endParaRPr lang="en-US"/>
           </a:p>
           <a:p>
             <a:pPr lvl="1"/>
@@ -7718,7 +7689,6 @@
               <a:rPr lang="en-US"/>
               <a:t>Second level</a:t>
             </a:r>
-            <a:endParaRPr lang="en-US"/>
           </a:p>
           <a:p>
             <a:pPr lvl="2"/>
@@ -7726,7 +7696,6 @@
               <a:rPr lang="en-US"/>
               <a:t>Third level</a:t>
             </a:r>
-            <a:endParaRPr lang="en-US"/>
           </a:p>
           <a:p>
             <a:pPr lvl="3"/>
@@ -7734,7 +7703,6 @@
               <a:rPr lang="en-US"/>
               <a:t>Fourth level</a:t>
             </a:r>
-            <a:endParaRPr lang="en-US"/>
           </a:p>
           <a:p>
             <a:pPr lvl="4"/>
@@ -7832,7 +7800,6 @@
               <a:rPr lang="en-US"/>
               <a:t>Edit Master text styles</a:t>
             </a:r>
-            <a:endParaRPr lang="en-US"/>
           </a:p>
         </p:txBody>
       </p:sp>
@@ -7853,6 +7820,7 @@
           <a:p>
             <a:fld id="{48A87A34-81AB-432B-8DAE-1953F412C126}" type="datetimeFigureOut">
               <a:rPr lang="en-US" smtClean="0"/>
+              <a:t>5/26/2026</a:t>
             </a:fld>
             <a:endParaRPr lang="en-US" dirty="0"/>
           </a:p>
@@ -7894,6 +7862,7 @@
           <a:p>
             <a:fld id="{6D22F896-40B5-4ADD-8801-0D06FADFA095}" type="slidenum">
               <a:rPr lang="en-US" smtClean="0"/>
+              <a:t>‹#›</a:t>
             </a:fld>
             <a:endParaRPr lang="en-US" dirty="0"/>
           </a:p>
@@ -8107,7 +8076,6 @@
               <a:rPr lang="en-US"/>
               <a:t>Edit Master text styles</a:t>
             </a:r>
-            <a:endParaRPr lang="en-US"/>
           </a:p>
         </p:txBody>
       </p:sp>
@@ -8128,6 +8096,7 @@
           <a:p>
             <a:fld id="{48A87A34-81AB-432B-8DAE-1953F412C126}" type="datetimeFigureOut">
               <a:rPr lang="en-US" smtClean="0"/>
+              <a:t>5/26/2026</a:t>
             </a:fld>
             <a:endParaRPr lang="en-US" dirty="0"/>
           </a:p>
@@ -8169,6 +8138,7 @@
           <a:p>
             <a:fld id="{6D22F896-40B5-4ADD-8801-0D06FADFA095}" type="slidenum">
               <a:rPr lang="en-US" smtClean="0"/>
+              <a:t>‹#›</a:t>
             </a:fld>
             <a:endParaRPr lang="en-US" dirty="0"/>
           </a:p>
@@ -8188,7 +8158,7 @@
     <p:bg>
       <p:bgPr>
         <a:blipFill dpi="0" rotWithShape="1">
-          <a:blip r:embed="rId18">
+          <a:blip r:embed="rId19">
             <a:lum/>
           </a:blip>
           <a:srcRect/>
@@ -8276,7 +8246,6 @@
               <a:rPr lang="en-US"/>
               <a:t>Edit Master text styles</a:t>
             </a:r>
-            <a:endParaRPr lang="en-US"/>
           </a:p>
           <a:p>
             <a:pPr lvl="1"/>
@@ -8284,7 +8253,6 @@
               <a:rPr lang="en-US"/>
               <a:t>Second level</a:t>
             </a:r>
-            <a:endParaRPr lang="en-US"/>
           </a:p>
           <a:p>
             <a:pPr lvl="2"/>
@@ -8292,7 +8260,6 @@
               <a:rPr lang="en-US"/>
               <a:t>Third level</a:t>
             </a:r>
-            <a:endParaRPr lang="en-US"/>
           </a:p>
           <a:p>
             <a:pPr lvl="3"/>
@@ -8300,7 +8267,6 @@
               <a:rPr lang="en-US"/>
               <a:t>Fourth level</a:t>
             </a:r>
-            <a:endParaRPr lang="en-US"/>
           </a:p>
           <a:p>
             <a:pPr lvl="4"/>
@@ -8365,6 +8331,7 @@
           <a:p>
             <a:fld id="{48A87A34-81AB-432B-8DAE-1953F412C126}" type="datetimeFigureOut">
               <a:rPr lang="en-US" smtClean="0"/>
+              <a:t>5/26/2026</a:t>
             </a:fld>
             <a:endParaRPr lang="en-US" dirty="0"/>
           </a:p>
@@ -8478,6 +8445,7 @@
           <a:p>
             <a:fld id="{6D22F896-40B5-4ADD-8801-0D06FADFA095}" type="slidenum">
               <a:rPr lang="en-US" smtClean="0"/>
+              <a:t>‹#›</a:t>
             </a:fld>
             <a:endParaRPr lang="en-US" dirty="0"/>
           </a:p>
@@ -9016,7 +8984,7 @@
               <a:rPr lang="en-US" altLang="zh-CN" sz="4000" dirty="0">
                 <a:ea typeface="黑体" panose="02010609060101010101" pitchFamily="49" charset="-122"/>
               </a:rPr>
-              <a:t>2019</a:t>
+              <a:t>2026</a:t>
             </a:r>
             <a:endParaRPr lang="zh-CN" altLang="en-US" sz="4000" dirty="0">
               <a:ea typeface="黑体" panose="02010609060101010101" pitchFamily="49" charset="-122"/>
@@ -9098,7 +9066,6 @@
               <a:rPr lang="zh-CN" altLang="en-US" dirty="0"/>
               <a:t>软件开发流程的目的是为了提高 软件开发、运营、维护的效率，并提高软件的质量、用户满意度、可靠性和软件的可维护性。</a:t>
             </a:r>
-            <a:endParaRPr lang="zh-CN" altLang="en-US" dirty="0"/>
           </a:p>
           <a:p>
             <a:endParaRPr lang="en-US" dirty="0"/>
@@ -9154,7 +9121,6 @@
               <a:rPr lang="en-US" dirty="0"/>
               <a:t>?</a:t>
             </a:r>
-            <a:endParaRPr lang="en-US" dirty="0"/>
           </a:p>
         </p:txBody>
       </p:sp>
@@ -9204,7 +9170,6 @@
               <a:rPr lang="en-US" dirty="0"/>
               <a:t>The effort is necessitated by the potential complexity of those systems, which may contain millions of lines of code.</a:t>
             </a:r>
-            <a:endParaRPr lang="en-US" dirty="0"/>
           </a:p>
           <a:p>
             <a:pPr eaLnBrk="1" hangingPunct="1"/>
@@ -9220,7 +9185,6 @@
               <a:rPr lang="en-US" dirty="0"/>
               <a:t>Millions of dollars, people’s life, business depends on it. </a:t>
             </a:r>
-            <a:endParaRPr lang="en-US" dirty="0"/>
           </a:p>
           <a:p>
             <a:pPr eaLnBrk="1" hangingPunct="1">
@@ -9308,8 +9272,20 @@
                 <a:tableStyleId>{5C22544A-7EE6-4342-B048-85BDC9FD1C3A}</a:tableStyleId>
               </a:tblPr>
               <a:tblGrid>
-                <a:gridCol w="7238999"/>
-                <a:gridCol w="1066804"/>
+                <a:gridCol w="7238999">
+                  <a:extLst>
+                    <a:ext uri="{9D8B030D-6E8A-4147-A177-3AD203B41FA5}">
+                      <a16:colId xmlns:a16="http://schemas.microsoft.com/office/drawing/2014/main" val="20000"/>
+                    </a:ext>
+                  </a:extLst>
+                </a:gridCol>
+                <a:gridCol w="1066804">
+                  <a:extLst>
+                    <a:ext uri="{9D8B030D-6E8A-4147-A177-3AD203B41FA5}">
+                      <a16:colId xmlns:a16="http://schemas.microsoft.com/office/drawing/2014/main" val="20001"/>
+                    </a:ext>
+                  </a:extLst>
+                </a:gridCol>
               </a:tblGrid>
               <a:tr h="370840">
                 <a:tc>
@@ -9321,7 +9297,6 @@
                         <a:rPr lang="en-US" dirty="0"/>
                         <a:t>Programming</a:t>
                       </a:r>
-                      <a:endParaRPr lang="en-US" dirty="0"/>
                     </a:p>
                   </a:txBody>
                   <a:tcPr/>
@@ -9344,6 +9319,11 @@
                   </a:txBody>
                   <a:tcPr/>
                 </a:tc>
+                <a:extLst>
+                  <a:ext uri="{0D108BD9-81ED-4DB2-BD59-A6C34878D82A}">
+                    <a16:rowId xmlns:a16="http://schemas.microsoft.com/office/drawing/2014/main" val="10000"/>
+                  </a:ext>
+                </a:extLst>
               </a:tr>
               <a:tr h="370840">
                 <a:tc>
@@ -9366,7 +9346,6 @@
                         <a:rPr lang="en-US" dirty="0"/>
                         <a:t>Children’s toy </a:t>
                       </a:r>
-                      <a:endParaRPr lang="en-US" dirty="0"/>
                     </a:p>
                     <a:p>
                       <a:pPr marL="640080" lvl="1" indent="-247015" eaLnBrk="1" fontAlgn="auto" hangingPunct="1">
@@ -9381,7 +9360,6 @@
                         <a:rPr lang="en-US" dirty="0"/>
                         <a:t>Write a “hello world” in a new language</a:t>
                       </a:r>
-                      <a:endParaRPr lang="en-US" dirty="0"/>
                     </a:p>
                     <a:p>
                       <a:pPr marL="640080" lvl="1" indent="-247015" eaLnBrk="1" fontAlgn="auto" hangingPunct="1">
@@ -9396,7 +9374,6 @@
                         <a:rPr lang="en-US" dirty="0"/>
                         <a:t>Time: one afternoon</a:t>
                       </a:r>
-                      <a:endParaRPr lang="en-US" dirty="0"/>
                     </a:p>
                   </a:txBody>
                   <a:tcPr/>
@@ -9411,6 +9388,11 @@
                   </a:txBody>
                   <a:tcPr/>
                 </a:tc>
+                <a:extLst>
+                  <a:ext uri="{0D108BD9-81ED-4DB2-BD59-A6C34878D82A}">
+                    <a16:rowId xmlns:a16="http://schemas.microsoft.com/office/drawing/2014/main" val="10001"/>
+                  </a:ext>
+                </a:extLst>
               </a:tr>
               <a:tr h="370840">
                 <a:tc>
@@ -9433,7 +9415,6 @@
                         <a:rPr lang="en-US" dirty="0"/>
                         <a:t>Hobbyist</a:t>
                       </a:r>
-                      <a:endParaRPr lang="en-US" dirty="0"/>
                     </a:p>
                     <a:p>
                       <a:pPr marL="640080" lvl="1" indent="-247015" eaLnBrk="1" fontAlgn="auto" hangingPunct="1">
@@ -9448,7 +9429,6 @@
                         <a:rPr lang="en-US" dirty="0"/>
                         <a:t>Try something new and cool in Perl, Python, Asp.net, etc. </a:t>
                       </a:r>
-                      <a:endParaRPr lang="en-US" dirty="0"/>
                     </a:p>
                     <a:p>
                       <a:pPr marL="640080" lvl="1" indent="-247015" eaLnBrk="1" fontAlgn="auto" hangingPunct="1">
@@ -9463,7 +9443,6 @@
                         <a:rPr lang="en-US" dirty="0"/>
                         <a:t>Time: a couple of days</a:t>
                       </a:r>
-                      <a:endParaRPr lang="en-US" dirty="0"/>
                     </a:p>
                   </a:txBody>
                   <a:tcPr/>
@@ -9478,6 +9457,11 @@
                   </a:txBody>
                   <a:tcPr/>
                 </a:tc>
+                <a:extLst>
+                  <a:ext uri="{0D108BD9-81ED-4DB2-BD59-A6C34878D82A}">
+                    <a16:rowId xmlns:a16="http://schemas.microsoft.com/office/drawing/2014/main" val="10002"/>
+                  </a:ext>
+                </a:extLst>
               </a:tr>
               <a:tr h="370840">
                 <a:tc>
@@ -9500,7 +9484,6 @@
                         <a:rPr lang="en-US" dirty="0"/>
                         <a:t>Prototype</a:t>
                       </a:r>
-                      <a:endParaRPr lang="en-US" dirty="0"/>
                     </a:p>
                     <a:p>
                       <a:pPr marL="640080" lvl="1" indent="-247015" eaLnBrk="1" fontAlgn="auto" hangingPunct="1">
@@ -9515,7 +9498,6 @@
                         <a:rPr lang="en-US" dirty="0"/>
                         <a:t>Write some web sites, tools for others to use</a:t>
                       </a:r>
-                      <a:endParaRPr lang="en-US" dirty="0"/>
                     </a:p>
                     <a:p>
                       <a:pPr marL="640080" lvl="1" indent="-247015" eaLnBrk="1" fontAlgn="auto" hangingPunct="1">
@@ -9530,7 +9512,6 @@
                         <a:rPr lang="en-US" dirty="0"/>
                         <a:t>Several weeks, months</a:t>
                       </a:r>
-                      <a:endParaRPr lang="en-US" dirty="0"/>
                     </a:p>
                   </a:txBody>
                   <a:tcPr/>
@@ -9545,6 +9526,11 @@
                   </a:txBody>
                   <a:tcPr/>
                 </a:tc>
+                <a:extLst>
+                  <a:ext uri="{0D108BD9-81ED-4DB2-BD59-A6C34878D82A}">
+                    <a16:rowId xmlns:a16="http://schemas.microsoft.com/office/drawing/2014/main" val="10003"/>
+                  </a:ext>
+                </a:extLst>
               </a:tr>
               <a:tr h="370840">
                 <a:tc>
@@ -9567,7 +9553,6 @@
                         <a:rPr lang="en-US" dirty="0"/>
                         <a:t>Professionals</a:t>
                       </a:r>
-                      <a:endParaRPr lang="en-US" dirty="0"/>
                     </a:p>
                     <a:p>
                       <a:pPr marL="640080" lvl="1" indent="-247015" eaLnBrk="1" fontAlgn="auto" hangingPunct="1">
@@ -9582,7 +9567,6 @@
                         <a:rPr lang="en-US" dirty="0"/>
                         <a:t>Make a living by writing software, like Bill Gates.</a:t>
                       </a:r>
-                      <a:endParaRPr lang="en-US" dirty="0"/>
                     </a:p>
                     <a:p>
                       <a:pPr marL="640080" lvl="1" indent="-247015" eaLnBrk="1" fontAlgn="auto" hangingPunct="1">
@@ -9597,7 +9581,6 @@
                         <a:rPr lang="en-US" dirty="0"/>
                         <a:t>Time: several years, several million/billion dollars. </a:t>
                       </a:r>
-                      <a:endParaRPr lang="en-US" dirty="0"/>
                     </a:p>
                   </a:txBody>
                   <a:tcPr/>
@@ -9612,6 +9595,11 @@
                   </a:txBody>
                   <a:tcPr/>
                 </a:tc>
+                <a:extLst>
+                  <a:ext uri="{0D108BD9-81ED-4DB2-BD59-A6C34878D82A}">
+                    <a16:rowId xmlns:a16="http://schemas.microsoft.com/office/drawing/2014/main" val="10004"/>
+                  </a:ext>
+                </a:extLst>
               </a:tr>
             </a:tbl>
           </a:graphicData>
@@ -9620,7 +9608,7 @@
       <p:pic>
         <p:nvPicPr>
           <p:cNvPr id="5" name="Picture 4" descr="http://tbn0.google.com/images?q=tbn:50QzruCKWotv6M:http://veronikanagy.files.wordpress.com/2008/02/paper_airplane_sm.jpg">
-            <a:hlinkClick r:id="rId1"/>
+            <a:hlinkClick r:id="rId2"/>
           </p:cNvPr>
           <p:cNvPicPr>
             <a:picLocks noChangeAspect="1" noChangeArrowheads="1"/>
@@ -9628,7 +9616,7 @@
           <p:nvPr/>
         </p:nvPicPr>
         <p:blipFill>
-          <a:blip r:embed="rId2">
+          <a:blip r:embed="rId3">
             <a:extLst>
               <a:ext uri="{28A0092B-C50C-407E-A947-70E740481C1C}">
                 <a14:useLocalDpi xmlns:a14="http://schemas.microsoft.com/office/drawing/2010/main" val="0"/>
@@ -9682,7 +9670,7 @@
           <p:nvPr/>
         </p:nvPicPr>
         <p:blipFill>
-          <a:blip r:embed="rId3" cstate="print">
+          <a:blip r:embed="rId4" cstate="print">
             <a:extLst>
               <a:ext uri="{28A0092B-C50C-407E-A947-70E740481C1C}">
                 <a14:useLocalDpi xmlns:a14="http://schemas.microsoft.com/office/drawing/2010/main" val="0"/>
@@ -9736,7 +9724,7 @@
           <p:nvPr/>
         </p:nvPicPr>
         <p:blipFill>
-          <a:blip r:embed="rId4" cstate="print">
+          <a:blip r:embed="rId5" cstate="print">
             <a:extLst>
               <a:ext uri="{28A0092B-C50C-407E-A947-70E740481C1C}">
                 <a14:useLocalDpi xmlns:a14="http://schemas.microsoft.com/office/drawing/2010/main" val="0"/>
@@ -9790,7 +9778,7 @@
           <p:nvPr/>
         </p:nvPicPr>
         <p:blipFill>
-          <a:blip r:embed="rId5" cstate="print">
+          <a:blip r:embed="rId6" cstate="print">
             <a:extLst>
               <a:ext uri="{28A0092B-C50C-407E-A947-70E740481C1C}">
                 <a14:useLocalDpi xmlns:a14="http://schemas.microsoft.com/office/drawing/2010/main" val="0"/>
@@ -9974,7 +9962,6 @@
               <a:rPr lang="en-US" dirty="0"/>
               <a:t>Service</a:t>
             </a:r>
-            <a:endParaRPr lang="en-US" dirty="0"/>
           </a:p>
         </p:txBody>
       </p:sp>
@@ -10018,7 +10005,6 @@
               <a:rPr lang="en-US" altLang="zh-CN" sz="2000" dirty="0"/>
               <a:t>:</a:t>
             </a:r>
-            <a:endParaRPr lang="en-US" altLang="zh-CN" sz="2000" dirty="0"/>
           </a:p>
           <a:p>
             <a:pPr lvl="1"/>
@@ -10026,7 +10012,6 @@
               <a:rPr lang="en-US" altLang="zh-CN" sz="1800" dirty="0"/>
               <a:t>C/C++</a:t>
             </a:r>
-            <a:endParaRPr lang="en-US" altLang="zh-CN" sz="1800" dirty="0"/>
           </a:p>
           <a:p>
             <a:pPr lvl="1"/>
@@ -10034,7 +10019,6 @@
               <a:rPr lang="en-US" altLang="zh-CN" sz="1800" dirty="0"/>
               <a:t>C#/VB.net/Java</a:t>
             </a:r>
-            <a:endParaRPr lang="en-US" altLang="zh-CN" sz="1800" dirty="0"/>
           </a:p>
           <a:p>
             <a:pPr lvl="1"/>
@@ -10042,7 +10026,6 @@
               <a:rPr lang="en-US" sz="1800" dirty="0"/>
               <a:t>Excel</a:t>
             </a:r>
-            <a:endParaRPr lang="en-US" sz="1800" dirty="0"/>
           </a:p>
           <a:p>
             <a:pPr lvl="1"/>
@@ -10050,7 +10033,6 @@
               <a:rPr lang="en-US" sz="1800" dirty="0"/>
               <a:t>Unix Shell</a:t>
             </a:r>
-            <a:endParaRPr lang="en-US" sz="1800" dirty="0"/>
           </a:p>
           <a:p>
             <a:pPr lvl="1"/>
@@ -10082,7 +10064,6 @@
               <a:rPr lang="en-US" sz="1800" dirty="0"/>
               <a:t>Perl</a:t>
             </a:r>
-            <a:endParaRPr lang="en-US" sz="1800" dirty="0"/>
           </a:p>
           <a:p>
             <a:pPr lvl="1"/>
@@ -10090,7 +10071,6 @@
               <a:rPr lang="en-US" sz="1800" dirty="0"/>
               <a:t>Python</a:t>
             </a:r>
-            <a:endParaRPr lang="en-US" sz="1800" dirty="0"/>
           </a:p>
           <a:p>
             <a:r>
@@ -10117,7 +10097,6 @@
               <a:rPr lang="en-US" altLang="zh-CN" sz="2200" dirty="0"/>
               <a:t>1】</a:t>
             </a:r>
-            <a:endParaRPr lang="en-US" altLang="zh-CN" sz="2200" dirty="0"/>
           </a:p>
           <a:p>
             <a:r>
@@ -10158,7 +10137,6 @@
               <a:rPr lang="en-US" altLang="zh-CN" sz="2200" dirty="0"/>
               <a:t>2】</a:t>
             </a:r>
-            <a:endParaRPr lang="en-US" altLang="zh-CN" sz="2200" dirty="0"/>
           </a:p>
           <a:p>
             <a:r>
@@ -10506,21 +10484,18 @@
               <a:rPr lang="en-US" dirty="0"/>
               <a:t>Program = data structure + algorithm</a:t>
             </a:r>
-            <a:endParaRPr lang="en-US" dirty="0"/>
           </a:p>
           <a:p>
             <a:r>
               <a:rPr lang="en-US" dirty="0"/>
               <a:t>Software = Program + Software Engineering</a:t>
             </a:r>
-            <a:endParaRPr lang="en-US" dirty="0"/>
           </a:p>
           <a:p>
             <a:r>
               <a:rPr lang="en-US" altLang="zh-CN" dirty="0"/>
               <a:t>Software Company = </a:t>
             </a:r>
-            <a:endParaRPr lang="en-US" altLang="zh-CN" dirty="0"/>
           </a:p>
           <a:p>
             <a:pPr marL="118745" indent="0">
@@ -10542,7 +10517,6 @@
               <a:rPr lang="en-US" altLang="zh-CN" dirty="0"/>
               <a:t>Model</a:t>
             </a:r>
-            <a:endParaRPr lang="en-US" altLang="zh-CN" dirty="0"/>
           </a:p>
           <a:p>
             <a:pPr marL="118745" indent="0">
@@ -10953,7 +10927,6 @@
               <a:rPr lang="en-US" dirty="0"/>
               <a:t>…</a:t>
             </a:r>
-            <a:endParaRPr lang="en-US" dirty="0"/>
           </a:p>
         </p:txBody>
       </p:sp>
@@ -10995,7 +10968,6 @@
               <a:rPr lang="en-US" sz="2000" dirty="0"/>
               <a:t>get a new one</a:t>
             </a:r>
-            <a:endParaRPr lang="en-US" sz="2000" dirty="0"/>
           </a:p>
           <a:p>
             <a:pPr eaLnBrk="1" hangingPunct="1"/>
@@ -11015,7 +10987,6 @@
               <a:rPr lang="en-US" sz="2000" dirty="0"/>
               <a:t>we had fun, move on… </a:t>
             </a:r>
-            <a:endParaRPr lang="en-US" sz="2000" dirty="0"/>
           </a:p>
           <a:p>
             <a:pPr eaLnBrk="1" hangingPunct="1"/>
@@ -11035,7 +11006,6 @@
               <a:rPr lang="en-US" sz="2000" dirty="0"/>
               <a:t>learn the lesson, find another way, and keep going…</a:t>
             </a:r>
-            <a:endParaRPr lang="en-US" sz="2000" dirty="0"/>
           </a:p>
           <a:p>
             <a:pPr eaLnBrk="1" hangingPunct="1"/>
@@ -11071,7 +11041,6 @@
               <a:rPr lang="en-US" sz="1700" dirty="0"/>
               <a:t>people’s life, money</a:t>
             </a:r>
-            <a:endParaRPr lang="en-US" sz="1700" dirty="0"/>
           </a:p>
           <a:p>
             <a:pPr lvl="1" eaLnBrk="1" hangingPunct="1"/>
@@ -11128,7 +11097,6 @@
               <a:rPr lang="en-US"/>
               <a:t>Quiz:</a:t>
             </a:r>
-            <a:endParaRPr lang="en-US"/>
           </a:p>
         </p:txBody>
       </p:sp>
@@ -11155,7 +11123,6 @@
               <a:rPr lang="en-US"/>
               <a:t>If a feature in a commercial product has 1-in-a-million chance of usage, do you want to build it and educate customer about it every time they use the product?</a:t>
             </a:r>
-            <a:endParaRPr lang="en-US"/>
           </a:p>
           <a:p>
             <a:pPr marL="984250" lvl="1" indent="-514350">
@@ -11166,7 +11133,6 @@
               <a:rPr lang="en-US"/>
               <a:t>don’t even plan it. </a:t>
             </a:r>
-            <a:endParaRPr lang="en-US"/>
           </a:p>
           <a:p>
             <a:pPr marL="984250" lvl="1" indent="-514350">
@@ -11177,7 +11143,6 @@
               <a:rPr lang="en-US"/>
               <a:t>cut it if we don’t have time. </a:t>
             </a:r>
-            <a:endParaRPr lang="en-US"/>
           </a:p>
           <a:p>
             <a:pPr marL="984250" lvl="1" indent="-514350">
@@ -11188,7 +11153,6 @@
               <a:rPr lang="en-US"/>
               <a:t>Build it, but don’t need to tell users</a:t>
             </a:r>
-            <a:endParaRPr lang="en-US"/>
           </a:p>
           <a:p>
             <a:pPr marL="984250" lvl="1" indent="-514350">
@@ -11199,7 +11163,6 @@
               <a:rPr lang="en-US"/>
               <a:t>Build it, tell uses about it</a:t>
             </a:r>
-            <a:endParaRPr lang="en-US"/>
           </a:p>
         </p:txBody>
       </p:sp>
@@ -11319,7 +11282,6 @@
               <a:rPr lang="en-US"/>
               <a:t>The answer is:</a:t>
             </a:r>
-            <a:endParaRPr lang="en-US"/>
           </a:p>
         </p:txBody>
       </p:sp>
@@ -11332,7 +11294,7 @@
           <p:nvPr/>
         </p:nvPicPr>
         <p:blipFill>
-          <a:blip r:embed="rId1">
+          <a:blip r:embed="rId2">
             <a:extLst>
               <a:ext uri="{28A0092B-C50C-407E-A947-70E740481C1C}">
                 <a14:useLocalDpi xmlns:a14="http://schemas.microsoft.com/office/drawing/2010/main" val="0"/>
@@ -11422,7 +11384,6 @@
               <a:rPr lang="en-US"/>
               <a:t>A hole</a:t>
             </a:r>
-            <a:endParaRPr lang="en-US"/>
           </a:p>
         </p:txBody>
       </p:sp>
@@ -11435,7 +11396,7 @@
           <p:nvPr/>
         </p:nvPicPr>
         <p:blipFill>
-          <a:blip r:embed="rId1">
+          <a:blip r:embed="rId3">
             <a:extLst>
               <a:ext uri="{28A0092B-C50C-407E-A947-70E740481C1C}">
                 <a14:useLocalDpi xmlns:a14="http://schemas.microsoft.com/office/drawing/2010/main" val="0"/>
@@ -11553,7 +11514,6 @@
               <a:rPr lang="en-US" dirty="0"/>
               <a:t>?</a:t>
             </a:r>
-            <a:endParaRPr lang="en-US" dirty="0"/>
           </a:p>
         </p:txBody>
       </p:sp>
@@ -11608,7 +11568,7 @@
       <p:pic>
         <p:nvPicPr>
           <p:cNvPr id="26627" name="Picture 2" descr="File:Plane crash into Hudson River (crop).jpg">
-            <a:hlinkClick r:id="rId1"/>
+            <a:hlinkClick r:id="rId3"/>
           </p:cNvPr>
           <p:cNvPicPr>
             <a:picLocks noChangeAspect="1" noChangeArrowheads="1"/>
@@ -11616,7 +11576,7 @@
           <p:nvPr/>
         </p:nvPicPr>
         <p:blipFill>
-          <a:blip r:embed="rId2">
+          <a:blip r:embed="rId4">
             <a:extLst>
               <a:ext uri="{28A0092B-C50C-407E-A947-70E740481C1C}">
                 <a14:useLocalDpi xmlns:a14="http://schemas.microsoft.com/office/drawing/2010/main" val="0"/>
@@ -11767,7 +11727,6 @@
               <a:rPr lang="en-US" altLang="zh-CN" dirty="0"/>
               <a:t>?</a:t>
             </a:r>
-            <a:endParaRPr lang="en-US" altLang="zh-CN" dirty="0"/>
           </a:p>
           <a:p>
             <a:r>
@@ -11874,7 +11833,6 @@
               <a:rPr lang="zh-CN" altLang="en-US" dirty="0"/>
               <a:t>行源代码（相当于显示器的一屏）， 他们的智力、记忆力和常人差不多。软件的各个模块之间有各种显性或 隐性的依赖关系，随着系统的成长和模块的增多，这些关系的数量往往以几何级数的速度增长。</a:t>
             </a:r>
-            <a:endParaRPr lang="zh-CN" altLang="en-US" dirty="0"/>
           </a:p>
           <a:p>
             <a:endParaRPr lang="en-US" dirty="0"/>
@@ -11973,7 +11931,6 @@
               <a:rPr lang="zh-CN" altLang="en-US" dirty="0"/>
               <a:t>商用软件出现 了错误，工程师可以看到程序在出错的一瞬间留下的一些痕迹（错误代号、 大致的目标代码位置、错误信息），但是几乎无法完整重现到底程序出 现了什么问题。</a:t>
             </a:r>
-            <a:endParaRPr lang="zh-CN" altLang="en-US" dirty="0"/>
           </a:p>
           <a:p>
             <a:r>
@@ -12103,7 +12060,6 @@
               <a:rPr lang="zh-CN" altLang="en-US" dirty="0"/>
               <a:t>但是与此同时，正确地修改软件是一件很困难的事情。</a:t>
             </a:r>
-            <a:endParaRPr lang="zh-CN" altLang="en-US" dirty="0"/>
           </a:p>
           <a:p>
             <a:endParaRPr lang="en-US" dirty="0"/>
@@ -12191,7 +12147,7 @@
           </p:nvPr>
         </p:nvPicPr>
         <p:blipFill>
-          <a:blip r:embed="rId1">
+          <a:blip r:embed="rId3">
             <a:extLst>
               <a:ext uri="{28A0092B-C50C-407E-A947-70E740481C1C}">
                 <a14:useLocalDpi xmlns:a14="http://schemas.microsoft.com/office/drawing/2010/main" val="0"/>
@@ -12292,7 +12248,6 @@
               <a:rPr lang="zh-CN" altLang="en-US" dirty="0"/>
               <a:t>） 软件不能独立存在，它总是要运行在硬件上面，它要服从系统中其他组 成部分的要求，它还要服从用户的要求、行业系统的要求（例如银行利 率的变化）。</a:t>
             </a:r>
-            <a:endParaRPr lang="zh-CN" altLang="en-US" dirty="0"/>
           </a:p>
           <a:p>
             <a:endParaRPr lang="en-US" dirty="0"/>
@@ -12344,14 +12299,13 @@
               <a:rPr lang="en-US"/>
               <a:t>Children’s toy</a:t>
             </a:r>
-            <a:endParaRPr lang="en-US"/>
           </a:p>
         </p:txBody>
       </p:sp>
       <p:pic>
         <p:nvPicPr>
           <p:cNvPr id="6147" name="Picture 4" descr="http://tbn0.google.com/images?q=tbn:50QzruCKWotv6M:http://veronikanagy.files.wordpress.com/2008/02/paper_airplane_sm.jpg">
-            <a:hlinkClick r:id="rId1"/>
+            <a:hlinkClick r:id="rId2"/>
           </p:cNvPr>
           <p:cNvPicPr>
             <a:picLocks noChangeAspect="1" noChangeArrowheads="1"/>
@@ -12359,7 +12313,7 @@
           <p:nvPr/>
         </p:nvPicPr>
         <p:blipFill>
-          <a:blip r:embed="rId2">
+          <a:blip r:embed="rId3">
             <a:extLst>
               <a:ext uri="{28A0092B-C50C-407E-A947-70E740481C1C}">
                 <a14:useLocalDpi xmlns:a14="http://schemas.microsoft.com/office/drawing/2010/main" val="0"/>
@@ -12486,7 +12440,6 @@
               <a:rPr lang="zh-CN" altLang="en-US" dirty="0"/>
               <a:t>但是许多软件系统却没有这样的特性，有时输入上很小的变化，会 引起输出上极大的变化。</a:t>
             </a:r>
-            <a:endParaRPr lang="zh-CN" altLang="en-US" dirty="0"/>
           </a:p>
           <a:p>
             <a:endParaRPr lang="en-US" dirty="0"/>
@@ -12660,7 +12613,6 @@
               <a:rPr lang="zh-CN" altLang="en-US" dirty="0"/>
               <a:t>社区</a:t>
             </a:r>
-            <a:endParaRPr lang="zh-CN" altLang="en-US" dirty="0"/>
           </a:p>
           <a:p>
             <a:pPr marL="118745" indent="0">
@@ -12796,7 +12748,6 @@
               <a:rPr lang="en-US" dirty="0"/>
               <a:t> and maintainability of software systems.</a:t>
             </a:r>
-            <a:endParaRPr lang="en-US" dirty="0"/>
           </a:p>
           <a:p>
             <a:pPr marL="457200" indent="-457200">
@@ -12830,7 +12781,6 @@
               <a:rPr lang="en-US" dirty="0"/>
               <a:t>Lack of quality = defect (bug)</a:t>
             </a:r>
-            <a:endParaRPr lang="en-US" dirty="0"/>
           </a:p>
         </p:txBody>
       </p:sp>
@@ -12919,7 +12869,6 @@
               <a:rPr lang="en-US" altLang="zh-CN" sz="2200" dirty="0"/>
               <a:t>3 lines of code</a:t>
             </a:r>
-            <a:endParaRPr lang="en-US" altLang="zh-CN" sz="2200" dirty="0"/>
           </a:p>
           <a:p>
             <a:pPr lvl="1" eaLnBrk="1" hangingPunct="1"/>
@@ -12927,7 +12876,6 @@
               <a:rPr lang="en-US" altLang="zh-CN" sz="2200" dirty="0"/>
               <a:t>Cost Microsoft 1Billion$</a:t>
             </a:r>
-            <a:endParaRPr lang="en-US" altLang="zh-CN" sz="2200" dirty="0"/>
           </a:p>
           <a:p>
             <a:pPr eaLnBrk="1" hangingPunct="1"/>
@@ -12935,7 +12883,6 @@
               <a:rPr lang="en-US" altLang="zh-CN" dirty="0"/>
               <a:t>MSFT research</a:t>
             </a:r>
-            <a:endParaRPr lang="en-US" altLang="zh-CN" dirty="0"/>
           </a:p>
           <a:p>
             <a:pPr lvl="1" eaLnBrk="1" hangingPunct="1"/>
@@ -12943,7 +12890,6 @@
               <a:rPr lang="en-US" altLang="zh-CN" sz="2200" dirty="0"/>
               <a:t>Bug cost 12 hours of extra work, about 900$</a:t>
             </a:r>
-            <a:endParaRPr lang="en-US" altLang="zh-CN" sz="2200" dirty="0"/>
           </a:p>
           <a:p>
             <a:pPr lvl="1" eaLnBrk="1" hangingPunct="1"/>
@@ -12955,7 +12901,6 @@
               <a:rPr lang="en-US" altLang="zh-CN" sz="2200" dirty="0"/>
               <a:t>missing)</a:t>
             </a:r>
-            <a:endParaRPr lang="en-US" altLang="zh-CN" sz="2200" dirty="0"/>
           </a:p>
         </p:txBody>
       </p:sp>
@@ -13124,7 +13069,6 @@
               <a:rPr lang="en-US" altLang="zh-CN" sz="2400" dirty="0"/>
               <a:t>  </a:t>
             </a:r>
-            <a:endParaRPr lang="en-US" altLang="zh-CN" sz="2400" dirty="0"/>
           </a:p>
           <a:p>
             <a:r>
@@ -13168,7 +13112,7 @@
           <p:nvPr/>
         </p:nvPicPr>
         <p:blipFill>
-          <a:blip r:embed="rId1">
+          <a:blip r:embed="rId2">
             <a:extLst>
               <a:ext uri="{28A0092B-C50C-407E-A947-70E740481C1C}">
                 <a14:useLocalDpi xmlns:a14="http://schemas.microsoft.com/office/drawing/2010/main" val="0"/>
@@ -13365,7 +13309,6 @@
               <a:rPr lang="en-US" altLang="zh-CN" sz="1800" dirty="0"/>
               <a:t>)</a:t>
             </a:r>
-            <a:endParaRPr lang="en-US" altLang="zh-CN" sz="1800" dirty="0"/>
           </a:p>
           <a:p>
             <a:pPr marL="633095" indent="-514350">
@@ -13395,7 +13338,6 @@
               <a:rPr lang="zh-CN" altLang="en-US" sz="1800" dirty="0"/>
               <a:t>的模块。</a:t>
             </a:r>
-            <a:endParaRPr lang="zh-CN" altLang="en-US" sz="1800" dirty="0"/>
           </a:p>
           <a:p>
             <a:pPr marL="633095" indent="-514350">
@@ -13475,7 +13417,6 @@
               <a:rPr lang="en-US" altLang="zh-CN" sz="1800" dirty="0"/>
               <a:t>-  </a:t>
             </a:r>
-            <a:endParaRPr lang="en-US" altLang="zh-CN" sz="1800" dirty="0"/>
           </a:p>
           <a:p>
             <a:pPr marL="925830" lvl="1" indent="-514350">
@@ -13513,7 +13454,6 @@
               <a:rPr lang="en-US" altLang="zh-CN" sz="1400" dirty="0"/>
               <a:t>…</a:t>
             </a:r>
-            <a:endParaRPr lang="en-US" altLang="zh-CN" sz="1400" dirty="0"/>
           </a:p>
           <a:p>
             <a:pPr marL="925830" lvl="1" indent="-514350">
@@ -13535,7 +13475,6 @@
               <a:rPr lang="en-US" altLang="zh-CN" sz="1400" dirty="0"/>
               <a:t>…</a:t>
             </a:r>
-            <a:endParaRPr lang="en-US" altLang="zh-CN" sz="1400" dirty="0"/>
           </a:p>
           <a:p>
             <a:pPr marL="925830" lvl="1" indent="-514350">
@@ -13557,7 +13496,6 @@
               <a:rPr lang="en-US" altLang="zh-CN" sz="1400" dirty="0"/>
               <a:t>…</a:t>
             </a:r>
-            <a:endParaRPr lang="en-US" altLang="zh-CN" sz="1400" dirty="0"/>
           </a:p>
           <a:p>
             <a:pPr marL="925830" lvl="1" indent="-514350">
@@ -13571,7 +13509,6 @@
               <a:rPr lang="zh-CN" altLang="en-US" sz="1400" dirty="0"/>
               <a:t>最后没有人再发邮件了</a:t>
             </a:r>
-            <a:endParaRPr lang="zh-CN" altLang="en-US" sz="1400" dirty="0"/>
           </a:p>
           <a:p>
             <a:pPr marL="633095" indent="-514350">
@@ -13621,7 +13558,6 @@
               <a:rPr lang="en-US" altLang="zh-CN" sz="1800" dirty="0"/>
               <a:t> </a:t>
             </a:r>
-            <a:endParaRPr lang="en-US" altLang="zh-CN" sz="1800" dirty="0"/>
           </a:p>
           <a:p>
             <a:pPr>
@@ -13710,7 +13646,6 @@
               <a:rPr lang="en-US" altLang="zh-CN" dirty="0"/>
               <a:t>1: </a:t>
             </a:r>
-            <a:endParaRPr lang="en-US" altLang="zh-CN" dirty="0"/>
           </a:p>
           <a:p>
             <a:pPr lvl="1"/>
@@ -13748,7 +13683,6 @@
               <a:rPr lang="en-US" altLang="zh-CN" dirty="0"/>
               <a:t>2: </a:t>
             </a:r>
-            <a:endParaRPr lang="en-US" altLang="zh-CN" dirty="0"/>
           </a:p>
           <a:p>
             <a:pPr lvl="1"/>
@@ -13874,7 +13808,6 @@
               <a:rPr lang="en-US" altLang="zh-CN" dirty="0"/>
               <a:t>bug</a:t>
             </a:r>
-            <a:endParaRPr lang="en-US" altLang="zh-CN" dirty="0"/>
           </a:p>
           <a:p>
             <a:pPr lvl="1"/>
@@ -14067,7 +14000,6 @@
               <a:rPr lang="en-US" altLang="zh-CN" sz="2000"/>
               <a:t>…</a:t>
             </a:r>
-            <a:endParaRPr lang="en-US" altLang="zh-CN" sz="2000"/>
           </a:p>
           <a:p>
             <a:pPr eaLnBrk="1" hangingPunct="1"/>
@@ -14079,7 +14011,6 @@
               <a:rPr lang="en-US" altLang="zh-CN" sz="2000"/>
               <a:t>…</a:t>
             </a:r>
-            <a:endParaRPr lang="en-US" altLang="zh-CN" sz="2000"/>
           </a:p>
           <a:p>
             <a:pPr eaLnBrk="1" hangingPunct="1"/>
@@ -14139,7 +14070,6 @@
               <a:rPr lang="en-US" altLang="zh-CN" sz="2000"/>
               <a:t>? </a:t>
             </a:r>
-            <a:endParaRPr lang="en-US" altLang="zh-CN" sz="2000"/>
           </a:p>
         </p:txBody>
       </p:sp>
@@ -14257,7 +14187,6 @@
               <a:rPr lang="en-US" altLang="zh-CN" dirty="0"/>
               <a:t>It’s a bug!</a:t>
             </a:r>
-            <a:endParaRPr lang="en-US" altLang="zh-CN" dirty="0"/>
           </a:p>
           <a:p>
             <a:pPr eaLnBrk="1" hangingPunct="1"/>
@@ -14360,7 +14289,6 @@
               <a:rPr lang="en-US"/>
               <a:t>Hobbyist: Lawn chair, balloon</a:t>
             </a:r>
-            <a:endParaRPr lang="en-US"/>
           </a:p>
         </p:txBody>
       </p:sp>
@@ -14373,7 +14301,7 @@
           <p:nvPr/>
         </p:nvPicPr>
         <p:blipFill>
-          <a:blip r:embed="rId1">
+          <a:blip r:embed="rId3">
             <a:extLst>
               <a:ext uri="{28A0092B-C50C-407E-A947-70E740481C1C}">
                 <a14:useLocalDpi xmlns:a14="http://schemas.microsoft.com/office/drawing/2010/main" val="0"/>
@@ -14462,7 +14390,6 @@
               <a:rPr lang="en-US" dirty="0"/>
               <a:t>User’s Perspective</a:t>
             </a:r>
-            <a:endParaRPr lang="en-US" dirty="0"/>
           </a:p>
         </p:txBody>
       </p:sp>
@@ -14500,7 +14427,6 @@
               <a:rPr lang="en-US" altLang="zh-CN" dirty="0"/>
               <a:t>QQ</a:t>
             </a:r>
-            <a:endParaRPr lang="en-US" altLang="zh-CN" dirty="0"/>
           </a:p>
           <a:p>
             <a:pPr lvl="1"/>
@@ -14520,7 +14446,6 @@
               <a:rPr lang="en-US" altLang="zh-CN" dirty="0"/>
               <a:t>BMW</a:t>
             </a:r>
-            <a:endParaRPr lang="en-US" altLang="zh-CN" dirty="0"/>
           </a:p>
           <a:p>
             <a:r>
@@ -14546,7 +14471,6 @@
               <a:rPr lang="en-US" altLang="zh-CN" dirty="0"/>
               <a:t>?</a:t>
             </a:r>
-            <a:endParaRPr lang="en-US" altLang="zh-CN" dirty="0"/>
           </a:p>
           <a:p>
             <a:r>
@@ -14566,7 +14490,7 @@
           <p:nvPr/>
         </p:nvPicPr>
         <p:blipFill>
-          <a:blip r:embed="rId1">
+          <a:blip r:embed="rId2">
             <a:extLst>
               <a:ext uri="{28A0092B-C50C-407E-A947-70E740481C1C}">
                 <a14:useLocalDpi xmlns:a14="http://schemas.microsoft.com/office/drawing/2010/main" val="0"/>
@@ -14630,7 +14554,7 @@
           <p:nvPr/>
         </p:nvPicPr>
         <p:blipFill>
-          <a:blip r:embed="rId2">
+          <a:blip r:embed="rId3">
             <a:extLst>
               <a:ext uri="{28A0092B-C50C-407E-A947-70E740481C1C}">
                 <a14:useLocalDpi xmlns:a14="http://schemas.microsoft.com/office/drawing/2010/main" val="0"/>
@@ -14694,7 +14618,7 @@
           <p:nvPr/>
         </p:nvPicPr>
         <p:blipFill>
-          <a:blip r:embed="rId3">
+          <a:blip r:embed="rId4">
             <a:extLst>
               <a:ext uri="{28A0092B-C50C-407E-A947-70E740481C1C}">
                 <a14:useLocalDpi xmlns:a14="http://schemas.microsoft.com/office/drawing/2010/main" val="0"/>
@@ -15020,7 +14944,7 @@
           </p:nvPr>
         </p:nvPicPr>
         <p:blipFill>
-          <a:blip r:embed="rId1">
+          <a:blip r:embed="rId2" cstate="print">
             <a:extLst>
               <a:ext uri="{28A0092B-C50C-407E-A947-70E740481C1C}">
                 <a14:useLocalDpi xmlns:a14="http://schemas.microsoft.com/office/drawing/2010/main" val="0"/>
@@ -15097,7 +15021,7 @@
           </p:nvPr>
         </p:nvPicPr>
         <p:blipFill>
-          <a:blip r:embed="rId1"/>
+          <a:blip r:embed="rId2"/>
           <a:stretch>
             <a:fillRect/>
           </a:stretch>
@@ -15329,7 +15253,7 @@
           <a:p>
             <a:r>
               <a:rPr lang="en-US" dirty="0">
-                <a:hlinkClick r:id="rId1"/>
+                <a:hlinkClick r:id="rId2"/>
               </a:rPr>
               <a:t>http://www.infoq.com/presentations/tony-hoare-computing-engineering</a:t>
             </a:r>
@@ -15337,13 +15261,13 @@
           </a:p>
           <a:p>
             <a:endParaRPr lang="en-US" dirty="0">
-              <a:hlinkClick r:id="rId1"/>
+              <a:hlinkClick r:id="rId2"/>
             </a:endParaRPr>
           </a:p>
           <a:p>
             <a:r>
               <a:rPr lang="en-US" dirty="0">
-                <a:hlinkClick r:id="rId1"/>
+                <a:hlinkClick r:id="rId2"/>
               </a:rPr>
               <a:t>http://pan.baidu.com/s/1pJuNp03</a:t>
             </a:r>
@@ -15558,9 +15482,6 @@
               </a:rPr>
               <a:t>：以在市场上赢得用户为目标而构建的软件。这也是种种科学发现、技 术突破最好的试金石。</a:t>
             </a:r>
-            <a:endParaRPr lang="zh-CN" altLang="en-US" dirty="0">
-              <a:latin typeface="+mn-ea"/>
-            </a:endParaRPr>
           </a:p>
         </p:txBody>
       </p:sp>
@@ -15824,7 +15745,7 @@
           <p:nvPr/>
         </p:nvPicPr>
         <p:blipFill>
-          <a:blip r:embed="rId1"/>
+          <a:blip r:embed="rId2"/>
           <a:stretch>
             <a:fillRect/>
           </a:stretch>
@@ -15985,7 +15906,6 @@
               <a:rPr lang="en-US" dirty="0"/>
               <a:t>Software Requirements</a:t>
             </a:r>
-            <a:endParaRPr lang="en-US" dirty="0"/>
           </a:p>
           <a:p>
             <a:pPr lvl="1"/>
@@ -15993,7 +15913,6 @@
               <a:rPr lang="en-US" dirty="0"/>
               <a:t>Software Design</a:t>
             </a:r>
-            <a:endParaRPr lang="en-US" dirty="0"/>
           </a:p>
           <a:p>
             <a:pPr lvl="1"/>
@@ -16001,7 +15920,6 @@
               <a:rPr lang="en-US" dirty="0"/>
               <a:t>Software Construction</a:t>
             </a:r>
-            <a:endParaRPr lang="en-US" dirty="0"/>
           </a:p>
           <a:p>
             <a:pPr lvl="1"/>
@@ -16009,7 +15927,6 @@
               <a:rPr lang="en-US" dirty="0"/>
               <a:t>Software Testing</a:t>
             </a:r>
-            <a:endParaRPr lang="en-US" dirty="0"/>
           </a:p>
           <a:p>
             <a:pPr lvl="1"/>
@@ -16017,7 +15934,6 @@
               <a:rPr lang="en-US" dirty="0"/>
               <a:t>Software Maintenance</a:t>
             </a:r>
-            <a:endParaRPr lang="en-US" dirty="0"/>
           </a:p>
           <a:p>
             <a:pPr lvl="1"/>
@@ -16025,7 +15941,6 @@
               <a:rPr lang="en-US" dirty="0"/>
               <a:t>Software Configuration Management</a:t>
             </a:r>
-            <a:endParaRPr lang="en-US" dirty="0"/>
           </a:p>
           <a:p>
             <a:pPr lvl="1"/>
@@ -16033,7 +15948,6 @@
               <a:rPr lang="en-US" dirty="0"/>
               <a:t>Software Engineering Management</a:t>
             </a:r>
-            <a:endParaRPr lang="en-US" dirty="0"/>
           </a:p>
           <a:p>
             <a:pPr lvl="1"/>
@@ -16041,7 +15955,6 @@
               <a:rPr lang="en-US" dirty="0"/>
               <a:t>Software Engineering Process</a:t>
             </a:r>
-            <a:endParaRPr lang="en-US" dirty="0"/>
           </a:p>
           <a:p>
             <a:pPr lvl="1"/>
@@ -16049,7 +15962,6 @@
               <a:rPr lang="en-US" dirty="0"/>
               <a:t>Software Engineering Models and Methods</a:t>
             </a:r>
-            <a:endParaRPr lang="en-US" dirty="0"/>
           </a:p>
           <a:p>
             <a:pPr lvl="1"/>
@@ -16057,7 +15969,6 @@
               <a:rPr lang="en-US" dirty="0"/>
               <a:t>Software Quality</a:t>
             </a:r>
-            <a:endParaRPr lang="en-US" dirty="0"/>
           </a:p>
           <a:p>
             <a:pPr lvl="1"/>
@@ -16065,7 +15976,6 @@
               <a:rPr lang="en-US" dirty="0"/>
               <a:t>Software Engineering Professional Practice</a:t>
             </a:r>
-            <a:endParaRPr lang="en-US" dirty="0"/>
           </a:p>
           <a:p>
             <a:pPr lvl="1"/>
@@ -16073,7 +15983,6 @@
               <a:rPr lang="en-US" dirty="0"/>
               <a:t>Software Engineering Economics</a:t>
             </a:r>
-            <a:endParaRPr lang="en-US" dirty="0"/>
           </a:p>
         </p:txBody>
       </p:sp>
@@ -16156,7 +16065,6 @@
               <a:rPr lang="en-US" dirty="0"/>
               <a:t> </a:t>
             </a:r>
-            <a:endParaRPr lang="en-US" dirty="0"/>
           </a:p>
           <a:p>
             <a:r>
@@ -16220,7 +16128,6 @@
               <a:rPr lang="en-US" dirty="0"/>
               <a:t>Prototype: Wright Brother</a:t>
             </a:r>
-            <a:endParaRPr lang="en-US" dirty="0"/>
           </a:p>
         </p:txBody>
       </p:sp>
@@ -16233,7 +16140,7 @@
           <p:nvPr/>
         </p:nvPicPr>
         <p:blipFill>
-          <a:blip r:embed="rId1">
+          <a:blip r:embed="rId2">
             <a:extLst>
               <a:ext uri="{28A0092B-C50C-407E-A947-70E740481C1C}">
                 <a14:useLocalDpi xmlns:a14="http://schemas.microsoft.com/office/drawing/2010/main" val="0"/>
@@ -16434,7 +16341,7 @@
           <p:nvPr/>
         </p:nvPicPr>
         <p:blipFill>
-          <a:blip r:embed="rId1">
+          <a:blip r:embed="rId2">
             <a:extLst>
               <a:ext uri="{28A0092B-C50C-407E-A947-70E740481C1C}">
                 <a14:useLocalDpi xmlns:a14="http://schemas.microsoft.com/office/drawing/2010/main" val="0"/>
@@ -16475,7 +16382,7 @@
           <p:nvPr/>
         </p:nvPicPr>
         <p:blipFill>
-          <a:blip r:embed="rId2">
+          <a:blip r:embed="rId3">
             <a:extLst>
               <a:ext uri="{28A0092B-C50C-407E-A947-70E740481C1C}">
                 <a14:useLocalDpi xmlns:a14="http://schemas.microsoft.com/office/drawing/2010/main" val="0"/>
@@ -16516,7 +16423,7 @@
           <p:nvPr/>
         </p:nvPicPr>
         <p:blipFill>
-          <a:blip r:embed="rId3">
+          <a:blip r:embed="rId4">
             <a:extLst>
               <a:ext uri="{28A0092B-C50C-407E-A947-70E740481C1C}">
                 <a14:useLocalDpi xmlns:a14="http://schemas.microsoft.com/office/drawing/2010/main" val="0"/>
@@ -16668,7 +16575,6 @@
               <a:rPr lang="en-US" b="1" dirty="0"/>
               <a:t> </a:t>
             </a:r>
-            <a:endParaRPr lang="en-US" b="1" dirty="0"/>
           </a:p>
           <a:p>
             <a:endParaRPr lang="en-US" altLang="zh-CN" dirty="0"/>
@@ -16900,7 +16806,6 @@
               <a:rPr lang="en-US" dirty="0"/>
               <a:t>Learning by doing. </a:t>
             </a:r>
-            <a:endParaRPr lang="en-US" dirty="0"/>
           </a:p>
         </p:txBody>
       </p:sp>
@@ -16994,7 +16899,6 @@
               <a:rPr lang="en-US" sz="2400" dirty="0"/>
               <a:t>ICSE (Intl Conference on Software Engineering)</a:t>
             </a:r>
-            <a:endParaRPr lang="en-US" sz="2400" dirty="0"/>
           </a:p>
           <a:p>
             <a:pPr lvl="1"/>
@@ -17010,7 +16914,6 @@
               <a:rPr lang="en-US" sz="2400" dirty="0"/>
               <a:t>)</a:t>
             </a:r>
-            <a:endParaRPr lang="en-US" sz="2400" dirty="0"/>
           </a:p>
           <a:p>
             <a:pPr lvl="1"/>
@@ -17018,7 +16921,6 @@
               <a:rPr lang="en-US" sz="2400" dirty="0"/>
               <a:t>ASE (Intl Conf on Automated Software Engineering)</a:t>
             </a:r>
-            <a:endParaRPr lang="en-US" sz="2400" dirty="0"/>
           </a:p>
         </p:txBody>
       </p:sp>
@@ -17178,7 +17080,7 @@
           <p:nvPr/>
         </p:nvPicPr>
         <p:blipFill>
-          <a:blip r:embed="rId1" cstate="print">
+          <a:blip r:embed="rId3" cstate="print">
             <a:extLst>
               <a:ext uri="{28A0092B-C50C-407E-A947-70E740481C1C}">
                 <a14:useLocalDpi xmlns:a14="http://schemas.microsoft.com/office/drawing/2010/main" val="0"/>
@@ -17208,7 +17110,7 @@
           <p:nvPr/>
         </p:nvPicPr>
         <p:blipFill>
-          <a:blip r:embed="rId2">
+          <a:blip r:embed="rId4">
             <a:extLst>
               <a:ext uri="{28A0092B-C50C-407E-A947-70E740481C1C}">
                 <a14:useLocalDpi xmlns:a14="http://schemas.microsoft.com/office/drawing/2010/main" val="0"/>
@@ -17238,7 +17140,7 @@
           <p:nvPr/>
         </p:nvPicPr>
         <p:blipFill>
-          <a:blip r:embed="rId3"/>
+          <a:blip r:embed="rId5"/>
           <a:stretch>
             <a:fillRect/>
           </a:stretch>
@@ -17262,7 +17164,7 @@
           <p:nvPr/>
         </p:nvPicPr>
         <p:blipFill>
-          <a:blip r:embed="rId4">
+          <a:blip r:embed="rId6">
             <a:extLst>
               <a:ext uri="{28A0092B-C50C-407E-A947-70E740481C1C}">
                 <a14:useLocalDpi xmlns:a14="http://schemas.microsoft.com/office/drawing/2010/main" val="0"/>
@@ -17292,7 +17194,7 @@
           <p:nvPr/>
         </p:nvPicPr>
         <p:blipFill>
-          <a:blip r:embed="rId5" cstate="print">
+          <a:blip r:embed="rId7" cstate="print">
             <a:extLst>
               <a:ext uri="{28A0092B-C50C-407E-A947-70E740481C1C}">
                 <a14:useLocalDpi xmlns:a14="http://schemas.microsoft.com/office/drawing/2010/main" val="0"/>
@@ -17763,7 +17665,6 @@
               <a:rPr lang="zh-CN" altLang="en-US" sz="2200" dirty="0"/>
               <a:t>这些软件的开发者是怎么说服你（陌生人）成为他们的用户的？他们的目标都是盈利么？他们的目标都是赚取用户的现金么？还是别的？ </a:t>
             </a:r>
-            <a:endParaRPr lang="zh-CN" altLang="en-US" sz="2200" dirty="0"/>
           </a:p>
           <a:p>
             <a:pPr lvl="1">
@@ -17783,7 +17684,6 @@
               <a:rPr lang="zh-CN" altLang="en-US" sz="2200" dirty="0"/>
               <a:t>） </a:t>
             </a:r>
-            <a:endParaRPr lang="zh-CN" altLang="en-US" sz="2200" dirty="0"/>
           </a:p>
           <a:p>
             <a:pPr lvl="1">
@@ -17803,7 +17703,6 @@
               <a:rPr lang="zh-CN" altLang="en-US" sz="2200" dirty="0"/>
               <a:t>么？又是如何更新新版本的？ </a:t>
             </a:r>
-            <a:endParaRPr lang="zh-CN" altLang="en-US" sz="2200" dirty="0"/>
           </a:p>
           <a:p>
             <a:pPr lvl="1">
@@ -17961,7 +17860,7 @@
           <a:p>
             <a:r>
               <a:rPr lang="en-US" dirty="0">
-                <a:hlinkClick r:id="rId1"/>
+                <a:hlinkClick r:id="rId2"/>
               </a:rPr>
               <a:t>http://www.cnblogs.com/xinz/p/3803035.html</a:t>
             </a:r>
@@ -18050,7 +17949,7 @@
             </a:pPr>
             <a:r>
               <a:rPr lang="en-US" altLang="zh-CN" sz="2000" dirty="0">
-                <a:hlinkClick r:id="rId1"/>
+                <a:hlinkClick r:id="rId2"/>
               </a:rPr>
               <a:t>http://zhuanlan.zhihu.com/goujianzhifa/20003750</a:t>
             </a:r>
@@ -18077,28 +17976,24 @@
               <a:rPr lang="en-US" altLang="zh-CN" dirty="0"/>
               <a:t>Build to Pass</a:t>
             </a:r>
-            <a:endParaRPr lang="en-US" altLang="zh-CN" dirty="0"/>
           </a:p>
           <a:p>
             <a:r>
               <a:rPr lang="en-US" dirty="0"/>
               <a:t>Build to Learn</a:t>
             </a:r>
-            <a:endParaRPr lang="en-US" dirty="0"/>
           </a:p>
           <a:p>
             <a:r>
               <a:rPr lang="en-US" dirty="0"/>
               <a:t>Build to Show</a:t>
             </a:r>
-            <a:endParaRPr lang="en-US" dirty="0"/>
           </a:p>
           <a:p>
             <a:r>
               <a:rPr lang="en-US" dirty="0"/>
               <a:t>Build to Win</a:t>
             </a:r>
-            <a:endParaRPr lang="en-US" dirty="0"/>
           </a:p>
         </p:txBody>
       </p:sp>
@@ -18147,7 +18042,6 @@
               <a:rPr lang="en-US"/>
               <a:t>Professional today: 66 Billion</a:t>
             </a:r>
-            <a:endParaRPr lang="en-US"/>
           </a:p>
         </p:txBody>
       </p:sp>
@@ -18160,7 +18054,7 @@
           <p:nvPr/>
         </p:nvPicPr>
         <p:blipFill>
-          <a:blip r:embed="rId1">
+          <a:blip r:embed="rId2">
             <a:extLst>
               <a:ext uri="{28A0092B-C50C-407E-A947-70E740481C1C}">
                 <a14:useLocalDpi xmlns:a14="http://schemas.microsoft.com/office/drawing/2010/main" val="0"/>
@@ -18295,7 +18189,6 @@
               <a:rPr lang="zh-CN" altLang="en-US" sz="2200" dirty="0"/>
               <a:t>是把系统的、有序的、可量化的方法应用到软件的开发、运营和维护上的过程。</a:t>
             </a:r>
-            <a:endParaRPr lang="zh-CN" altLang="en-US" sz="2200" dirty="0"/>
           </a:p>
           <a:p>
             <a:pPr marL="5080" indent="-5080">
@@ -18322,7 +18215,6 @@
               <a:rPr lang="zh-CN" altLang="en-US" sz="2200" dirty="0"/>
               <a:t>软件需求分析、软件设计、软件构建、软件测试和软件维护。</a:t>
             </a:r>
-            <a:endParaRPr lang="zh-CN" altLang="en-US" sz="2200" dirty="0"/>
           </a:p>
           <a:p>
             <a:pPr marL="5080" indent="-5080">
@@ -18349,7 +18241,6 @@
               <a:rPr lang="zh-CN" altLang="en-US" sz="2200" dirty="0"/>
               <a:t>计算机科学、计算机工程、管理学、数学、项目管理学、质量管理、</a:t>
             </a:r>
-            <a:endParaRPr lang="zh-CN" altLang="en-US" sz="2200" dirty="0"/>
           </a:p>
           <a:p>
             <a:pPr marL="5080" indent="-5080">
@@ -18363,7 +18254,6 @@
               <a:rPr lang="zh-CN" altLang="en-US" sz="2200" dirty="0"/>
               <a:t>软件人体工学、系统工程、工业设计和用户界面设计。</a:t>
             </a:r>
-            <a:endParaRPr lang="zh-CN" altLang="en-US" sz="2200" dirty="0"/>
           </a:p>
         </p:txBody>
       </p:sp>
@@ -18411,7 +18301,6 @@
               <a:rPr lang="en-US" dirty="0"/>
               <a:t>What is Software Engineering</a:t>
             </a:r>
-            <a:endParaRPr lang="en-US" dirty="0"/>
           </a:p>
         </p:txBody>
       </p:sp>
@@ -18449,7 +18338,6 @@
               <a:rPr lang="en-US" sz="2400" b="1" dirty="0"/>
               <a:t>software. </a:t>
             </a:r>
-            <a:endParaRPr lang="en-US" sz="2400" b="1" dirty="0"/>
           </a:p>
           <a:p>
             <a:pPr marL="5080" indent="-5080">
@@ -18464,7 +18352,6 @@
               <a:rPr lang="en-US" sz="2400" dirty="0"/>
               <a:t>Disciplines</a:t>
             </a:r>
-            <a:endParaRPr lang="en-US" sz="2400" dirty="0"/>
           </a:p>
           <a:p>
             <a:pPr marL="443230" lvl="1" indent="-5080">
@@ -18476,7 +18363,6 @@
               <a:rPr lang="en-US" sz="2000" dirty="0"/>
               <a:t>Software requirement, design, construction, testing and maintenance. </a:t>
             </a:r>
-            <a:endParaRPr lang="en-US" sz="2000" dirty="0"/>
           </a:p>
           <a:p>
             <a:pPr marL="5080" indent="-5080">
@@ -18491,7 +18377,6 @@
               <a:rPr lang="en-US" sz="2400" dirty="0"/>
               <a:t>Related fields:</a:t>
             </a:r>
-            <a:endParaRPr lang="en-US" sz="2400" dirty="0"/>
           </a:p>
           <a:p>
             <a:pPr marL="443230" lvl="1" indent="-5080">
@@ -18502,7 +18387,6 @@
               <a:rPr lang="en-US" sz="2000" dirty="0"/>
               <a:t>Computer Science, Computer Engineering, management, mathematics, project management, quality management, software ergonomics (usability), system engineering,  industrial design, UI design</a:t>
             </a:r>
-            <a:endParaRPr lang="en-US" sz="2000" dirty="0"/>
           </a:p>
           <a:p>
             <a:pPr marL="5080" indent="-5080">
@@ -18829,6 +18713,8 @@
       </a:bgFillStyleLst>
     </a:fmtScheme>
   </a:themeElements>
+  <a:objectDefaults/>
+  <a:extraClrSchemeLst/>
   <a:extLst>
     <a:ext uri="{05A4C25C-085E-4340-85A3-A5531E510DB2}">
       <thm15:themeFamily xmlns:thm15="http://schemas.microsoft.com/office/thememl/2012/main" name="Office Theme" id="{62F939B6-93AF-4DB8-9C6B-D6C7DFDC589F}" vid="{4A3C46E8-61CC-4603-A589-7422A47A8E4A}"/>
@@ -19115,6 +19001,8 @@
       </a:bgFillStyleLst>
     </a:fmtScheme>
   </a:themeElements>
+  <a:objectDefaults/>
+  <a:extraClrSchemeLst/>
   <a:extLst>
     <a:ext uri="{05A4C25C-085E-4340-85A3-A5531E510DB2}">
       <thm15:themeFamily xmlns:thm15="http://schemas.microsoft.com/office/thememl/2012/main" name="Office Theme" id="{62F939B6-93AF-4DB8-9C6B-D6C7DFDC589F}" vid="{4A3C46E8-61CC-4603-A589-7422A47A8E4A}"/>
@@ -19124,6 +19012,15 @@
 </file>
 
 <file path=customXml/item1.xml><?xml version="1.0" encoding="utf-8"?>
+<?mso-contentType ?>
+<FormTemplates xmlns="http://schemas.microsoft.com/sharepoint/v3/contenttype/forms">
+  <Display>DocumentLibraryForm</Display>
+  <Edit>DocumentLibraryForm</Edit>
+  <New>DocumentLibraryForm</New>
+</FormTemplates>
+</file>
+
+<file path=customXml/item2.xml><?xml version="1.0" encoding="utf-8"?>
 <ct:contentTypeSchema xmlns:ct="http://schemas.microsoft.com/office/2006/metadata/contentType" xmlns:ma="http://schemas.microsoft.com/office/2006/metadata/properties/metaAttributes" ct:_="" ma:_="" ma:contentTypeName="Document" ma:contentTypeID="0x0101006371182FA640024E8A2815D490E1EF25" ma:contentTypeVersion="0" ma:contentTypeDescription="Create a new document." ma:contentTypeScope="" ma:versionID="3591aab47f172a2900f307f59d422227">
   <xsd:schema xmlns:xsd="http://www.w3.org/2001/XMLSchema" xmlns:xs="http://www.w3.org/2001/XMLSchema" xmlns:p="http://schemas.microsoft.com/office/2006/metadata/properties" targetNamespace="http://schemas.microsoft.com/office/2006/metadata/properties" ma:root="true" ma:fieldsID="1f28ea01430cdfb20a10736313f817e3">
     <xsd:element name="properties">
@@ -19237,35 +19134,26 @@
 </ct:contentTypeSchema>
 </file>
 
-<file path=customXml/item2.xml><?xml version="1.0" encoding="utf-8"?>
+<file path=customXml/item3.xml><?xml version="1.0" encoding="utf-8"?>
 <p:properties xmlns:p="http://schemas.microsoft.com/office/2006/metadata/properties" xmlns:xsi="http://www.w3.org/2001/XMLSchema-instance" xmlns:pc="http://schemas.microsoft.com/office/infopath/2007/PartnerControls">
   <documentManagement/>
 </p:properties>
 </file>
 
-<file path=customXml/item3.xml><?xml version="1.0" encoding="utf-8"?>
-<?mso-contentType ?>
-<FormTemplates xmlns="http://schemas.microsoft.com/sharepoint/v3/contenttype/forms">
-  <Display>DocumentLibraryForm</Display>
-  <Edit>DocumentLibraryForm</Edit>
-  <New>DocumentLibraryForm</New>
-</FormTemplates>
+<file path=customXml/itemProps1.xml><?xml version="1.0" encoding="utf-8"?>
+<ds:datastoreItem xmlns:ds="http://schemas.openxmlformats.org/officeDocument/2006/customXml" ds:itemID="{152C3F0E-25C3-4B31-B914-3A618B652002}">
+  <ds:schemaRefs/>
+</ds:datastoreItem>
 </file>
 
-<file path=customXml/itemProps1.xml><?xml version="1.0" encoding="utf-8"?>
+<file path=customXml/itemProps2.xml><?xml version="1.0" encoding="utf-8"?>
 <ds:datastoreItem xmlns:ds="http://schemas.openxmlformats.org/officeDocument/2006/customXml" ds:itemID="{3A578484-EFC7-41EF-A5B1-C62DDCF2E328}">
   <ds:schemaRefs/>
 </ds:datastoreItem>
 </file>
 
-<file path=customXml/itemProps2.xml><?xml version="1.0" encoding="utf-8"?>
+<file path=customXml/itemProps3.xml><?xml version="1.0" encoding="utf-8"?>
 <ds:datastoreItem xmlns:ds="http://schemas.openxmlformats.org/officeDocument/2006/customXml" ds:itemID="{D5495DD4-04CD-4725-AADE-F45F611A52AA}">
   <ds:schemaRefs/>
 </ds:datastoreItem>
-</file>
-
-<file path=customXml/itemProps3.xml><?xml version="1.0" encoding="utf-8"?>
-<ds:datastoreItem xmlns:ds="http://schemas.openxmlformats.org/officeDocument/2006/customXml" ds:itemID="{152C3F0E-25C3-4B31-B914-3A618B652002}">
-  <ds:schemaRefs/>
-</ds:datastoreItem>
 </file>
</xml_diff>